<commit_message>
docs(deliverables): rebuild the report and the 15-slide deck
Built with scripts/build_deliverables.sh, without the logo, after every check passed. The report changes only in Figure 2's labels; the deck gains the two foundation slides. The checksums are refreshed.
</commit_message>
<xml_diff>
--- a/deliverables/Phase-I-Slides.pptx
+++ b/deliverables/Phase-I-Slides.pptx
@@ -5,7 +5,7 @@
     <p:sldMasterId id="2147483648" r:id="rId1"/>
   </p:sldMasterIdLst>
   <p:notesMasterIdLst>
-    <p:notesMasterId r:id="rId16"/>
+    <p:notesMasterId r:id="rId17"/>
   </p:notesMasterIdLst>
   <p:sldIdLst>
     <p:sldId id="256" r:id="rId2"/>
@@ -22,6 +22,7 @@
     <p:sldId id="267" r:id="rId13"/>
     <p:sldId id="268" r:id="rId14"/>
     <p:sldId id="269" r:id="rId15"/>
+    <p:sldId id="270" r:id="rId16"/>
   </p:sldIdLst>
   <p:sldSz cx="9144000" cy="5143500" type="screen16x9"/>
   <p:notesSz cx="6858000" cy="9144000"/>
@@ -537,7 +538,7 @@
             </a:pPr>
             <a:r>
               <a:rPr/>
-              <a:t>Our question is simple: when an alert threshold is allowed to learn from recent data, what should it learn from? Here is the common answer going wrong. This threshold only learns from scores it already called normal. Every score it admits is at or below it, so it can only stay or fall. Score 9 is normal at step one and an alert at step six, though nothing about the signal changed. The opposite fix, learning from everything, lets a long fault become the new normal. Our research sits between those two failures.</a:t>
+              <a:t>First, the setting, in half a minute. A machine carries sensors. We use one: the current drawn by the electric motor of a water-circulation rig, from SKAB, a public laboratory benchmark. The signal is cut into short windows. A fixed scorer, which is not our contribution, gives each window an anomaly score: higher means more unusual. A policy turns each score into a decision; the simplest one alerts when the score is above a threshold. An operator then checks every alert. So the system can fail in two ways: it can miss a real fault, or it can raise false alerts, and each false alert spends someone’s time. Our research is about the policy, box three.</a:t>
             </a:r>
           </a:p>
         </p:txBody>
@@ -619,7 +620,7 @@
             </a:pPr>
             <a:r>
               <a:rPr/>
-              <a:t>Each marker is one policy: to the right means it decided on more windows, lower means less false-alert time. On SKAB nearly every policy decides on every window. On the benign step our controller is quiet while still deciding everywhere, whereas Sun et al. are quiet by abstaining. That is why we always report coverage beside workload.</a:t>
+              <a:t>The controller in one table. With no sustained rise it behaves like a fixed threshold. When the recent median rises and the rise is stable and inside four times the calibration threshold, it recalibrates. If the rise is unstable it defers, up to ten times, then escalates and keeps alerting without learning. When the rise ends it returns toward the anchor. The parameters come from the existing baseline or are declared assumptions; none was chosen by looking at results.</a:t>
             </a:r>
           </a:p>
         </p:txBody>
@@ -701,7 +702,7 @@
             </a:pPr>
             <a:r>
               <a:rPr/>
-              <a:t>This is the slide we most want to be honest on. On the benign cases the simplest rule, learning from every window, is quieter than ours: 12 against 16, and 28 against 204. Our only argument is that we keep faults visible: 0.29 of the Y3 fault against 0.04. On SKAB we are identical to fixed, so it proves nothing either way. We therefore claim a mechanism and a finding, not a winner.</a:t>
+              <a:t>These engineered cases show the mechanism and its failures. On a clean benign step it adapts and cuts false-alert time from 597 to 16 while deciding on every window. After adapting it still catches later faults. On a slow ramp it locks into repeated alerts, a real failure we report. And a fault shaped exactly like a benign step is absorbed; we declared that limit in advance, because no label-free rule can tell the two apart.</a:t>
             </a:r>
           </a:p>
         </p:txBody>
@@ -783,7 +784,7 @@
             </a:pPr>
             <a:r>
               <a:rPr/>
-              <a:t>To separate cleanly what we know from what we do not. We have a proof, measured costs, a working controller and a no-harm result. We have not shown any real-world benefit or any held-out result, and we make no claim about the reserved stream. The data limits are real: one event per stream, one channel, and provenance we could not fully verify.</a:t>
+              <a:t>Each marker is one policy: to the right means it decided on more windows, lower means less false-alert time. On SKAB nearly every policy decides on every window. On the benign step our controller is quiet while still deciding everywhere, whereas Sun et al. are quiet by abstaining. That is why we always report coverage beside workload.</a:t>
             </a:r>
           </a:p>
         </p:txBody>
@@ -865,7 +866,7 @@
             </a:pPr>
             <a:r>
               <a:rPr/>
-              <a:t>Finally, the experiment that settles it, committed in advance so we cannot move the goalposts. We replay every policy on the other SKAB valve files, chosen without looking at labels, plus a dataset with genuine benign shifts. Any one of three outcomes kills the direction, and then that becomes our result. Thank you; we are happy to take questions.</a:t>
+              <a:t>This is the slide we most want to be honest on. On the benign cases the simplest rule, learning from every window, is quieter than ours: 12 against 16, and 28 against 204. Our only argument is that we keep faults visible: 0.29 of the Y3 fault against 0.04. On SKAB we are identical to fixed, so it proves nothing either way. We therefore claim a mechanism and a finding, not a winner.</a:t>
             </a:r>
           </a:p>
         </p:txBody>
@@ -888,6 +889,88 @@
             <a:fld id="{18BDFEC3-8487-43E8-A154-7C12CBC1FFF2}" type="slidenum">
               <a:rPr lang="en-US"/>
               <a:t>14</a:t>
+            </a:fld>
+            <a:endParaRPr lang="en-US"/>
+          </a:p>
+        </p:txBody>
+      </p:sp>
+    </p:spTree>
+  </p:cSld>
+</p:notes>
+</file>
+
+<file path=ppt/notesSlides/notesSlide14.xml><?xml version="1.0" encoding="utf-8"?>
+<p:notes xmlns:a="http://schemas.openxmlformats.org/drawingml/2006/main" xmlns:r="http://schemas.openxmlformats.org/officeDocument/2006/relationships" xmlns:p="http://schemas.openxmlformats.org/presentationml/2006/main">
+  <p:cSld>
+    <p:spTree>
+      <p:nvGrpSpPr>
+        <p:cNvPr id="1" name=""/>
+        <p:cNvGrpSpPr/>
+        <p:nvPr/>
+      </p:nvGrpSpPr>
+      <p:grpSpPr>
+        <a:xfrm>
+          <a:off x="0" y="0"/>
+          <a:ext cx="0" cy="0"/>
+          <a:chOff x="0" y="0"/>
+          <a:chExt cx="0" cy="0"/>
+        </a:xfrm>
+      </p:grpSpPr>
+      <p:sp>
+        <p:nvSpPr>
+          <p:cNvPr id="2" name="Slide Image Placeholder 1"/>
+          <p:cNvSpPr>
+            <a:spLocks noGrp="1" noRot="1" noChangeAspect="1"/>
+          </p:cNvSpPr>
+          <p:nvPr>
+            <p:ph type="sldImg"/>
+          </p:nvPr>
+        </p:nvSpPr>
+        <p:spPr/>
+      </p:sp>
+      <p:sp>
+        <p:nvSpPr>
+          <p:cNvPr id="3" name="Notes Placeholder 2"/>
+          <p:cNvSpPr>
+            <a:spLocks noGrp="1"/>
+          </p:cNvSpPr>
+          <p:nvPr>
+            <p:ph type="body" idx="1"/>
+          </p:nvPr>
+        </p:nvSpPr>
+        <p:spPr/>
+        <p:txBody>
+          <a:bodyPr/>
+          <a:lstStyle/>
+          <a:p>
+            <a:pPr lvl="0" indent="0" marL="0">
+              <a:buNone/>
+            </a:pPr>
+            <a:r>
+              <a:rPr/>
+              <a:t>To close, what we have not shown and how we will find out. We have no real-world benefit and no held-out result, the data has one event per stream on one channel, and we make no claim about the reserved stream. The next experiment is committed in advance, so we cannot move the goalposts: every policy is replayed on the other SKAB valve files, chosen without looking at labels, plus a dataset with genuine benign shifts. Any one of three outcomes kills the direction, and then that becomes our result. Thank you; we are happy to take questions.</a:t>
+            </a:r>
+          </a:p>
+        </p:txBody>
+      </p:sp>
+      <p:sp>
+        <p:nvSpPr>
+          <p:cNvPr id="4" name="Slide Number Placeholder 3"/>
+          <p:cNvSpPr>
+            <a:spLocks noGrp="1"/>
+          </p:cNvSpPr>
+          <p:nvPr>
+            <p:ph type="sldNum" sz="quarter" idx="10"/>
+          </p:nvPr>
+        </p:nvSpPr>
+        <p:spPr/>
+        <p:txBody>
+          <a:bodyPr/>
+          <a:lstStyle/>
+          <a:p>
+            <a:fld id="{18BDFEC3-8487-43E8-A154-7C12CBC1FFF2}" type="slidenum">
+              <a:rPr lang="en-US"/>
+              <a:t>15</a:t>
             </a:fld>
             <a:endParaRPr lang="en-US"/>
           </a:p>
@@ -947,7 +1030,7 @@
             </a:pPr>
             <a:r>
               <a:rPr/>
-              <a:t>This is our direction in one sentence: treat recalibration as a deliberate decision, learn from data the threshold did not choose for itself, and compare every option on exactly the same scores. The tags matter. Proved means a theorem. Measured means a saved, recomputed result. Implemented means tested code. Proposed means not yet tested. We have one proof, several measurements, a working controller, and an honest gap: we have not yet shown a benefit on real data.</a:t>
+              <a:t>The threshold starts at theta-zero, set once on early data. But normal drifts. After a repair or under a new load the whole signal can sit higher, and a fixed threshold then alerts all the time. So real systems let the threshold learn from recent scores; this is called recalibration. The question is what it should learn from. If it learns only from windows it already called normal, it can only move down: the solid blue line. If it learns from every window, a long fault pulls it up until the fault looks normal: the dashed line. Ours is the orange line: it waits while a rise is unconfirmed, then learns only as a guarded decision and stays inside the shaded band. The next slide shows the first failure with six numbers.</a:t>
             </a:r>
           </a:p>
         </p:txBody>
@@ -1029,7 +1112,7 @@
             </a:pPr>
             <a:r>
               <a:rPr/>
-              <a:t>Every examiner question of the form “isn’t this just X” is answered by this table. FITNESS already names the failure, so we do not claim it; we claim a proof for quantile thresholds. Sun et al. already abstain, so we re-implemented their method and measured it on our scores. Drift methods retrain the model; we freeze it. Hu already evaluates by workload; we borrow that. What we did not find, in nine papers, is policies compared on one fixed score trace. We say “not found”, never “does not exist”.</a:t>
+              <a:t>Here is the first failure, worked by hand. This threshold learns only from scores it already called normal, and sets itself to the largest of its last three. Every score it admits is at or below it, so it can only stay the same or fall. Score 9 is normal at step one and an alert at step six, though nothing about the signal changed: the alert comes from the threshold. Run that for a long time and ordinary scores become alerts.</a:t>
             </a:r>
           </a:p>
         </p:txBody>
@@ -1111,7 +1194,7 @@
             </a:pPr>
             <a:r>
               <a:rPr/>
-              <a:t>This is the pipeline, and it is mostly discipline. Each stream is cut in time into a fitting part, a calibration part and a replay part. The scorer is fit once and frozen. One score trace goes to every policy, so any difference we report comes from the policy, never from the scorer. Predictions are saved before labels are read. The reserved stream in the manifest was never opened.</a:t>
+              <a:t>This is our direction in one sentence: treat recalibration as a deliberate decision, learn from data the threshold did not choose for itself, and compare every policy on exactly the same scores, so a difference can only come from the policy. Read the tags as a strength scale, from a theorem down to an untested proposal. We have one proof, several measurements, a working controller, and an honest gap: we have not yet shown a benefit on real data.</a:t>
             </a:r>
           </a:p>
         </p:txBody>
@@ -1193,7 +1276,7 @@
             </a:pPr>
             <a:r>
               <a:rPr/>
-              <a:t>The one thing we prove: if a threshold admits only what it called normal and sets itself to a quantile of that buffer, it can never go up, for any data. The proof is a short rank argument. The saved SKAB traces agree: zero increases, and the threshold slides from 1.3 to 0.26 on valve1 and from 1.13 to 0.41 on valve2, below the typical score. That sinking line is why the rolling baseline alerts so often.</a:t>
+              <a:t>Every examiner question of the form “isn’t this just X” is answered by this table. FITNESS already names the failure, so we do not claim it; we claim a proof for quantile thresholds. Sun et al. already abstain, so we re-implemented their method and measured it on our scores. Drift methods retrain the model; we freeze it. Hu already evaluates by workload; we borrow that. What we did not find, in nine papers, is policies compared on one fixed score trace. We say “not found”, never “does not exist”.</a:t>
             </a:r>
           </a:p>
         </p:txBody>
@@ -1275,7 +1358,7 @@
             </a:pPr>
             <a:r>
               <a:rPr/>
-              <a:t>The SKAB table, read narrowly. Every arm that alerts finds the one event per stream. What separates them is workload. The normal-only rolling arm needs 16 times the alert windows on valve1 and nearly 4 times on valve2 for the same event: the ratchet’s cost. Our controller is identical to fixed, because its guard never fires on this data. That is a no-harm check, not a win. Sun et al. look quiet only because they decide on about 40 percent of windows.</a:t>
+              <a:t>This is the pipeline, and it is mostly discipline. Each stream is cut in time into a fitting part, a calibration part and a replay part. The scorer is fit once and frozen. One score trace goes to every policy, like setting every student the same exam, so any difference we report comes from the policy, never from the scorer. Predictions are saved before labels are read, so no policy can peek at the answers. The reserved stream in the manifest was never opened.</a:t>
             </a:r>
           </a:p>
         </p:txBody>
@@ -1357,7 +1440,7 @@
             </a:pPr>
             <a:r>
               <a:rPr/>
-              <a:t>Why do the persistence rules miss the events? Because of the scorer. Inside the event only 6 of 100 windows on valve1 and 13 of 98 on valve2 even cross the threshold, and never more than two in a row. A rule that waits for three in a row has nothing to fire on. And since each event covers most of the replay, one alert anywhere scores full recall, so on SKAB we read workload and false episodes, not recall.</a:t>
+              <a:t>The one thing we prove: if a threshold admits only what it called normal and sets itself to a quantile of that buffer, it can never go up, for any data. The proof is a short rank argument. The saved SKAB traces agree: zero increases, and the threshold slides from 1.3 to 0.26 on valve1 and from 1.13 to 0.41 on valve2, below the typical score. That sinking line is why the rolling baseline alerts so often.</a:t>
             </a:r>
           </a:p>
         </p:txBody>
@@ -1439,7 +1522,7 @@
             </a:pPr>
             <a:r>
               <a:rPr/>
-              <a:t>The controller in one table. With no sustained rise it behaves like a fixed threshold. When the recent median rises and the rise is stable and inside four times the calibration threshold, it recalibrates. If the rise is unstable it defers, up to ten times, then escalates and keeps alerting without learning. When the rise ends it returns toward the anchor. The parameters come from the existing baseline or are declared assumptions; none was chosen by looking at results.</a:t>
+              <a:t>The SKAB table, read narrowly. Every policy that alerts finds the one event per stream. What separates them is workload. The normal-only rolling policy needs 16 times the alert windows on valve1 and nearly 4 times on valve2 for the same event: the ratchet’s cost. Our controller is identical to fixed, because its guard never fires on this data. That is a no-harm check, not a win. Sun et al. look quiet only because they decide on about 40 percent of windows.</a:t>
             </a:r>
           </a:p>
         </p:txBody>
@@ -1521,7 +1604,7 @@
             </a:pPr>
             <a:r>
               <a:rPr/>
-              <a:t>These engineered cases show the mechanism and its failures. On a clean benign step it adapts and cuts false-alert time from 597 to 16 while deciding on every window. After adapting it still catches later faults. On a slow ramp it locks into repeated alerts, a real failure we report. And a fault shaped exactly like a benign step is absorbed; we declared that limit in advance, because no label-free rule can tell the two apart.</a:t>
+              <a:t>Why do the persistence rules miss the events? Because of the scorer. Inside the event only 6 of 100 windows on valve1 and 13 of 98 on valve2 even cross the threshold, and never more than two in a row. A rule that waits for three in a row has nothing to fire on. And since each event covers most of the replay, one alert anywhere scores full recall, so on SKAB we read workload and false episodes, not recall.</a:t>
             </a:r>
           </a:p>
         </p:txBody>
@@ -4644,6 +4727,180 @@
             <p:ph type="title"/>
           </p:nvPr>
         </p:nvSpPr>
+        <p:spPr>
+          <a:xfrm>
+            <a:off x="457201" y="204787"/>
+            <a:ext cx="3008313" cy="871538"/>
+          </a:xfrm>
+        </p:spPr>
+        <p:txBody>
+          <a:bodyPr/>
+          <a:lstStyle/>
+          <a:p>
+            <a:pPr lvl="0" indent="0" marL="0">
+              <a:buNone/>
+            </a:pPr>
+            <a:r>
+              <a:rPr/>
+              <a:t>The scorer, not the policy, limits detection on SKAB</a:t>
+            </a:r>
+          </a:p>
+        </p:txBody>
+      </p:sp>
+      <mc:AlternateContent xmlns:mc="http://schemas.openxmlformats.org/markup-compatibility/2006">
+        <mc:Choice xmlns:a14="http://schemas.microsoft.com/office/drawing/2010/main" Requires="a14">
+          <p:sp>
+            <p:nvSpPr>
+              <p:cNvPr id="4" name="Text Placeholder 3"/>
+              <p:cNvSpPr>
+                <a:spLocks noGrp="1"/>
+              </p:cNvSpPr>
+              <p:nvPr>
+                <p:ph idx="2" sz="half" type="body"/>
+              </p:nvPr>
+            </p:nvSpPr>
+            <p:spPr/>
+            <p:txBody>
+              <a:bodyPr/>
+              <a:lstStyle/>
+              <a:p>
+                <a:pPr lvl="0" indent="0" marL="0">
+                  <a:buNone/>
+                </a:pPr>
+                <a:r>
+                  <a:rPr b="1"/>
+                  <a:t>[MEASURED]</a:t>
+                </a:r>
+                <a:r>
+                  <a:rPr/>
+                  <a:t> Only </a:t>
+                </a:r>
+                <a:r>
+                  <a:rPr b="1"/>
+                  <a:t>6/100</a:t>
+                </a:r>
+                <a:r>
+                  <a:rPr/>
+                  <a:t> (valve1) and </a:t>
+                </a:r>
+                <a:r>
+                  <a:rPr b="1"/>
+                  <a:t>13/98</a:t>
+                </a:r>
+                <a:r>
+                  <a:rPr/>
+                  <a:t> (valve2) in-event windows exceed </a:t>
+                </a:r>
+                <a14:m>
+                  <m:oMath xmlns:m="http://schemas.openxmlformats.org/officeDocument/2006/math">
+                    <m:sSub>
+                      <m:e>
+                        <m:r>
+                          <m:t>θ</m:t>
+                        </m:r>
+                      </m:e>
+                      <m:sub>
+                        <m:r>
+                          <m:t>0</m:t>
+                        </m:r>
+                      </m:sub>
+                    </m:sSub>
+                  </m:oMath>
+                </a14:m>
+                <a:r>
+                  <a:rPr/>
+                  <a:t>, never more than </a:t>
+                </a:r>
+                <a:r>
+                  <a:rPr b="1"/>
+                  <a:t>2</a:t>
+                </a:r>
+                <a:r>
+                  <a:rPr/>
+                  <a:t> in a row, so rules needing 3 miss the events. Each event spans about </a:t>
+                </a:r>
+                <a:r>
+                  <a:rPr b="1"/>
+                  <a:t>70%</a:t>
+                </a:r>
+                <a:r>
+                  <a:rPr/>
+                  <a:t> of replay, so recall 1/1 says little. </a:t>
+                </a:r>
+                <a:r>
+                  <a:rPr b="1"/>
+                  <a:t>A policy can move alerts in time; it cannot create separation the scorer lacks.</a:t>
+                </a:r>
+              </a:p>
+            </p:txBody>
+          </p:sp>
+        </mc:Choice>
+      </mc:AlternateContent>
+      <p:pic>
+        <p:nvPicPr>
+          <p:cNvPr descr="figures/fig-scorer-limit.png" id="0" name="Picture 1"/>
+          <p:cNvPicPr>
+            <a:picLocks noGrp="1" noChangeAspect="1"/>
+          </p:cNvPicPr>
+          <p:nvPr/>
+        </p:nvPicPr>
+        <p:blipFill>
+          <a:blip r:embed="rId3"/>
+          <a:stretch>
+            <a:fillRect/>
+          </a:stretch>
+        </p:blipFill>
+        <p:spPr bwMode="auto">
+          <a:xfrm>
+            <a:off x="3568700" y="1447800"/>
+            <a:ext cx="5105400" cy="1879600"/>
+          </a:xfrm>
+          <a:prstGeom prst="rect">
+            <a:avLst/>
+          </a:prstGeom>
+          <a:noFill/>
+          <a:ln w="9525">
+            <a:noFill/>
+            <a:headEnd/>
+            <a:tailEnd/>
+          </a:ln>
+        </p:spPr>
+      </p:pic>
+    </p:spTree>
+  </p:cSld>
+</p:sld>
+</file>
+
+<file path=ppt/slides/slide11.xml><?xml version="1.0" encoding="UTF-8"?><p:sld xmlns:a="http://schemas.openxmlformats.org/drawingml/2006/main" xmlns:r="http://schemas.openxmlformats.org/officeDocument/2006/relationships" xmlns:p="http://schemas.openxmlformats.org/presentationml/2006/main"><p:cSld><p:spTree><p:nvGrpSpPr><p:cNvPr id="1" name="" /><p:cNvGrpSpPr /><p:nvPr /></p:nvGrpSpPr><p:grpSpPr><a:xfrm><a:off x="0" y="0" /><a:ext cx="0" cy="0" /><a:chOff x="0" y="0" /><a:chExt cx="0" cy="0" /></a:xfrm></p:grpSpPr><p:sp><p:nvSpPr><p:cNvPr id="2" name="Title 1" /><p:cNvSpPr><a:spLocks noGrp="1" /></p:cNvSpPr><p:nvPr><p:ph type="title" /></p:nvPr></p:nvSpPr><p:spPr><a:xfrm><a:off x="457201" y="204787" /><a:ext cx="3008313" cy="871538" /></a:xfrm></p:spPr><p:txBody><a:bodyPr /><a:lstStyle /><a:p><a:pPr lvl="0" indent="0" marL="0"><a:buNone /></a:pPr><a:r><a:rPr /><a:t>The controller: four actions, recalibration only inside a bounded band</a:t></a:r></a:p></p:txBody></p:sp><p:sp><p:nvSpPr><p:cNvPr id="4" name="Text Placeholder 3" /><p:cNvSpPr><a:spLocks noGrp="1" /></p:cNvSpPr><p:nvPr><p:ph idx="2" sz="half" type="body" /></p:nvPr></p:nvSpPr><p:spPr /><p:txBody><a:bodyPr /><a:lstStyle /><a:p><a:pPr lvl="0" indent="0" marL="0"><a:buNone /></a:pPr><a:r><a:rPr b="1" /><a:t>[IMPLEMENTED]</a:t></a:r><a:r><a:rPr /><a:t> </a:t></a:r><a:r><a:rPr><a:latin typeface="Courier" /></a:rPr><a:t>AnchoredRecalibrationPolicy</a:t></a:r><a:r><a:rPr /><a:t>. Its buffer holds the last 10 scores of </a:t></a:r><a:r><a:rPr b="1" /><a:t>every</a:t></a:r><a:r><a:rPr /><a:t> window, so what it learns from never depends on its own decisions. Nothing was tuned: 10 and 0.95 are the rolling baseline’s values; the cap 4 and the stability bound 2 are declared operating assumptions.</a:t></a:r></a:p></p:txBody></p:sp><p:graphicFrame><p:nvGraphicFramePr><p:cNvPr id="6" name="Content Placeholder 5" /><p:cNvGraphicFramePr><a:graphicFrameLocks noGrp="1" /></p:cNvGraphicFramePr><p:nvPr><p:ph idx="1" /></p:nvPr></p:nvGraphicFramePr><p:xfrm><a:off x="3568700" y="203200" /><a:ext cx="5105400" cy="4381500" /></p:xfrm><a:graphic><a:graphicData uri="http://schemas.openxmlformats.org/drawingml/2006/table"><a:tbl><a:tblPr firstRow="1" bandRow="1"><a:tableStyleId>{5C22544A-7EE6-4342-B048-85BDC9FD1C3A}</a:tableStyleId></a:tblPr><a:tblGrid><a:gridCol w="2819400" /><a:gridCol w="2286000" /></a:tblGrid><a:tr h="0"><a:tc><a:txBody><a:bodyPr /><a:lstStyle /><a:p><a:pPr lvl="0" indent="0" marL="0" algn="l"><a:buNone /></a:pPr><a:r><a:rPr /><a:t>At a window end</a:t></a:r></a:p></a:txBody><a:tcPr /></a:tc><a:tc><a:txBody><a:bodyPr /><a:lstStyle /><a:p><a:pPr lvl="0" indent="0" marL="0" algn="l"><a:buNone /></a:pPr><a:r><a:rPr /><a:t>Action</a:t></a:r></a:p></a:txBody><a:tcPr /></a:tc></a:tr><a:tr h="0"><a:tc><a:txBody><a:bodyPr /><a:lstStyle /><a:p><a:pPr lvl="0" indent="0" marL="0" algn="l"><a:buNone /></a:pPr><a:r><a:rPr /><a:t>No sustained rise</a:t></a:r></a:p></a:txBody></a:tc><a:tc><a:txBody><a:bodyPr /><a:lstStyle /><a:p><a:pPr lvl="0" indent="0" marL="0" algn="l"><a:buNone /></a:pPr><a:r><a:rPr b="1" /><a:t>hold</a:t></a:r><a:r><a:rPr /><a:t>, or </a:t></a:r><a:r><a:rPr b="1" /><a:t>alert</a:t></a:r><a:r><a:rPr /><a:t> if </a:t></a:r><a14:m><m:oMath xmlns:m="http://schemas.openxmlformats.org/officeDocument/2006/math"><m:r><m:t>s</m:t></m:r><m:r><m:rPr><m:sty m:val="p" /></m:rPr><m:t>&gt;</m:t></m:r><m:r><m:t>θ</m:t></m:r></m:oMath></a14:m></a:p></a:txBody></a:tc></a:tr><a:tr h="0"><a:tc><a:txBody><a:bodyPr /><a:lstStyle /><a:p><a:pPr lvl="0" indent="0" marL="0" algn="l"><a:buNone /></a:pPr><a:r><a:rPr /><a:t>Sustained rise that is stable and at most </a:t></a:r><a14:m><m:oMath xmlns:m="http://schemas.openxmlformats.org/officeDocument/2006/math"><m:r><m:t>4</m:t></m:r><m:sSub><m:e><m:r><m:t>θ</m:t></m:r></m:e><m:sub><m:r><m:t>0</m:t></m:r></m:sub></m:sSub></m:oMath></a14:m></a:p></a:txBody></a:tc><a:tc><a:txBody><a:bodyPr /><a:lstStyle /><a:p><a:pPr lvl="0" indent="0" marL="0" algn="l"><a:buNone /></a:pPr><a:r><a:rPr b="1" /><a:t>recalibrate</a:t></a:r><a:r><a:rPr /><a:t> up to it</a:t></a:r></a:p></a:txBody></a:tc></a:tr><a:tr h="0"><a:tc><a:txBody><a:bodyPr /><a:lstStyle /><a:p><a:pPr lvl="0" indent="0" marL="0" algn="l"><a:buNone /></a:pPr><a:r><a:rPr /><a:t>Sustained rise, guard fails</a:t></a:r></a:p></a:txBody></a:tc><a:tc><a:txBody><a:bodyPr /><a:lstStyle /><a:p><a:pPr lvl="0" indent="0" marL="0" algn="l"><a:buNone /></a:pPr><a:r><a:rPr b="1" /><a:t>defer</a:t></a:r><a:r><a:rPr /><a:t>, at most 10 in a row</a:t></a:r></a:p></a:txBody></a:tc></a:tr><a:tr h="0"><a:tc><a:txBody><a:bodyPr /><a:lstStyle /><a:p><a:pPr lvl="0" indent="0" marL="0" algn="l"><a:buNone /></a:pPr><a:r><a:rPr /><a:t>Still failing after 10 deferrals</a:t></a:r></a:p></a:txBody></a:tc><a:tc><a:txBody><a:bodyPr /><a:lstStyle /><a:p><a:pPr lvl="0" indent="0" marL="0" algn="l"><a:buNone /></a:pPr><a:r><a:rPr b="1" /><a:t>escalate</a:t></a:r><a:r><a:rPr /><a:t>: alert-capable, no recalibration</a:t></a:r></a:p></a:txBody></a:tc></a:tr><a:tr h="0"><a:tc><a:txBody><a:bodyPr /><a:lstStyle /><a:p><a:pPr lvl="0" indent="0" marL="0" algn="l"><a:buNone /></a:pPr><a:r><a:rPr /><a:t>Rise over</a:t></a:r></a:p></a:txBody></a:tc><a:tc><a:txBody><a:bodyPr /><a:lstStyle /><a:p><a:pPr lvl="0" indent="0" marL="0" algn="l"><a:buNone /></a:pPr><a:r><a:rPr b="1" /><a:t>recalibrate</a:t></a:r><a:r><a:rPr /><a:t> back toward </a:t></a:r><a14:m><m:oMath xmlns:m="http://schemas.openxmlformats.org/officeDocument/2006/math"><m:sSub><m:e><m:r><m:t>θ</m:t></m:r></m:e><m:sub><m:r><m:t>0</m:t></m:r></m:sub></m:sSub></m:oMath></a14:m></a:p></a:txBody></a:tc></a:tr></a:tbl></a:graphicData></a:graphic></p:graphicFrame></p:spTree></p:cSld></p:sld>
+</file>
+
+<file path=ppt/slides/slide12.xml><?xml version="1.0" encoding="utf-8"?>
+<p:sld xmlns:a="http://schemas.openxmlformats.org/drawingml/2006/main" xmlns:r="http://schemas.openxmlformats.org/officeDocument/2006/relationships" xmlns:p="http://schemas.openxmlformats.org/presentationml/2006/main">
+  <p:cSld>
+    <p:spTree>
+      <p:nvGrpSpPr>
+        <p:cNvPr id="1" name=""/>
+        <p:cNvGrpSpPr/>
+        <p:nvPr/>
+      </p:nvGrpSpPr>
+      <p:grpSpPr>
+        <a:xfrm>
+          <a:off x="0" y="0"/>
+          <a:ext cx="0" cy="0"/>
+          <a:chOff x="0" y="0"/>
+          <a:chExt cx="0" cy="0"/>
+        </a:xfrm>
+      </p:grpSpPr>
+      <p:sp>
+        <p:nvSpPr>
+          <p:cNvPr id="2" name="Title 1"/>
+          <p:cNvSpPr>
+            <a:spLocks noGrp="1"/>
+          </p:cNvSpPr>
+          <p:nvPr>
+            <p:ph type="title"/>
+          </p:nvPr>
+        </p:nvSpPr>
         <p:spPr/>
         <p:txBody>
           <a:bodyPr/>
@@ -4783,7 +5040,7 @@
 </p:sld>
 </file>
 
-<file path=ppt/slides/slide11.xml><?xml version="1.0" encoding="utf-8"?>
+<file path=ppt/slides/slide13.xml><?xml version="1.0" encoding="utf-8"?>
 <p:sld xmlns:a="http://schemas.openxmlformats.org/drawingml/2006/main" xmlns:r="http://schemas.openxmlformats.org/officeDocument/2006/relationships" xmlns:p="http://schemas.openxmlformats.org/presentationml/2006/main">
   <p:cSld>
     <p:spTree>
@@ -4935,349 +5192,6 @@
 </p:sld>
 </file>
 
-<file path=ppt/slides/slide12.xml><?xml version="1.0" encoding="utf-8"?>
-<p:sld xmlns:a="http://schemas.openxmlformats.org/drawingml/2006/main" xmlns:r="http://schemas.openxmlformats.org/officeDocument/2006/relationships" xmlns:p="http://schemas.openxmlformats.org/presentationml/2006/main">
-  <p:cSld>
-    <p:spTree>
-      <p:nvGrpSpPr>
-        <p:cNvPr id="1" name=""/>
-        <p:cNvGrpSpPr/>
-        <p:nvPr/>
-      </p:nvGrpSpPr>
-      <p:grpSpPr>
-        <a:xfrm>
-          <a:off x="0" y="0"/>
-          <a:ext cx="0" cy="0"/>
-          <a:chOff x="0" y="0"/>
-          <a:chExt cx="0" cy="0"/>
-        </a:xfrm>
-      </p:grpSpPr>
-      <p:sp>
-        <p:nvSpPr>
-          <p:cNvPr id="2" name="Title 1"/>
-          <p:cNvSpPr>
-            <a:spLocks noGrp="1"/>
-          </p:cNvSpPr>
-          <p:nvPr>
-            <p:ph type="title"/>
-          </p:nvPr>
-        </p:nvSpPr>
-        <p:spPr/>
-        <p:txBody>
-          <a:bodyPr/>
-          <a:lstStyle/>
-          <a:p>
-            <a:pPr lvl="0" indent="0" marL="0">
-              <a:buNone/>
-            </a:pPr>
-            <a:r>
-              <a:rPr/>
-              <a:t>The strongest case against us: a simpler rule is quieter</a:t>
-            </a:r>
-          </a:p>
-        </p:txBody>
-      </p:sp>
-      <p:sp>
-        <p:nvSpPr>
-          <p:cNvPr id="3" name="Content Placeholder 2"/>
-          <p:cNvSpPr>
-            <a:spLocks noGrp="1"/>
-          </p:cNvSpPr>
-          <p:nvPr>
-            <p:ph idx="1"/>
-          </p:nvPr>
-        </p:nvSpPr>
-        <p:spPr/>
-        <p:txBody>
-          <a:bodyPr/>
-          <a:lstStyle/>
-          <a:p>
-            <a:pPr lvl="0" indent="0" marL="0">
-              <a:buNone/>
-            </a:pPr>
-            <a:r>
-              <a:rPr b="1"/>
-              <a:t>These results do not establish a useful controller.</a:t>
-            </a:r>
-          </a:p>
-          <a:p>
-            <a:pPr lvl="0"/>
-            <a:r>
-              <a:rPr b="1"/>
-              <a:t>Admit-all is quieter on benign shifts:</a:t>
-            </a:r>
-            <a:r>
-              <a:rPr/>
-              <a:t> false-alert time 12 vs our 16 on Y1, and 28 vs our </a:t>
-            </a:r>
-            <a:r>
-              <a:rPr b="1"/>
-              <a:t>204</a:t>
-            </a:r>
-            <a:r>
-              <a:rPr/>
-              <a:t> on Y2.</a:t>
-            </a:r>
-          </a:p>
-          <a:p>
-            <a:pPr lvl="0"/>
-            <a:r>
-              <a:rPr b="1"/>
-              <a:t>Our only edge is keeping faults visible:</a:t>
-            </a:r>
-            <a:r>
-              <a:rPr/>
-              <a:t> on Y3 it alerts 0.29 of the fault against admit-all’s 0.04, both at recall 1/1.</a:t>
-            </a:r>
-          </a:p>
-          <a:p>
-            <a:pPr lvl="0"/>
-            <a:r>
-              <a:rPr b="1"/>
-              <a:t>SKAB gives no evidence either way:</a:t>
-            </a:r>
-            <a:r>
-              <a:rPr/>
-              <a:t> our rows are identical to fixed.</a:t>
-            </a:r>
-          </a:p>
-          <a:p>
-            <a:pPr lvl="0"/>
-            <a:r>
-              <a:rPr b="1"/>
-              <a:t>Abstention buys quiet with coverage:</a:t>
-            </a:r>
-            <a:r>
-              <a:rPr/>
-              <a:t> Sun et al. decide on 54/143 and 57/140 windows.</a:t>
-            </a:r>
-          </a:p>
-          <a:p>
-            <a:pPr lvl="0" indent="0" marL="0">
-              <a:buNone/>
-            </a:pPr>
-            <a:r>
-              <a:rPr b="1"/>
-              <a:t>What we claim instead:</a:t>
-            </a:r>
-            <a:r>
-              <a:rPr/>
-              <a:t> a proved mechanism, an honest negative-to-inconclusive development finding, and a test that can refute the direction.</a:t>
-            </a:r>
-          </a:p>
-        </p:txBody>
-      </p:sp>
-    </p:spTree>
-  </p:cSld>
-</p:sld>
-</file>
-
-<file path=ppt/slides/slide13.xml><?xml version="1.0" encoding="utf-8"?>
-<p:sld xmlns:a="http://schemas.openxmlformats.org/drawingml/2006/main" xmlns:r="http://schemas.openxmlformats.org/officeDocument/2006/relationships" xmlns:p="http://schemas.openxmlformats.org/presentationml/2006/main">
-  <p:cSld>
-    <p:spTree>
-      <p:nvGrpSpPr>
-        <p:cNvPr id="1" name=""/>
-        <p:cNvGrpSpPr/>
-        <p:nvPr/>
-      </p:nvGrpSpPr>
-      <p:grpSpPr>
-        <a:xfrm>
-          <a:off x="0" y="0"/>
-          <a:ext cx="0" cy="0"/>
-          <a:chOff x="0" y="0"/>
-          <a:chExt cx="0" cy="0"/>
-        </a:xfrm>
-      </p:grpSpPr>
-      <p:sp>
-        <p:nvSpPr>
-          <p:cNvPr id="2" name="Title 1"/>
-          <p:cNvSpPr>
-            <a:spLocks noGrp="1"/>
-          </p:cNvSpPr>
-          <p:nvPr>
-            <p:ph type="title"/>
-          </p:nvPr>
-        </p:nvSpPr>
-        <p:spPr/>
-        <p:txBody>
-          <a:bodyPr/>
-          <a:lstStyle/>
-          <a:p>
-            <a:pPr lvl="0" indent="0" marL="0">
-              <a:buNone/>
-            </a:pPr>
-            <a:r>
-              <a:rPr/>
-              <a:t>What Phase-I shows, and what it does not</a:t>
-            </a:r>
-          </a:p>
-        </p:txBody>
-      </p:sp>
-      <p:sp>
-        <p:nvSpPr>
-          <p:cNvPr id="3" name="Content Placeholder 2"/>
-          <p:cNvSpPr>
-            <a:spLocks noGrp="1"/>
-          </p:cNvSpPr>
-          <p:nvPr>
-            <p:ph idx="1" sz="half"/>
-          </p:nvPr>
-        </p:nvSpPr>
-        <p:spPr/>
-        <p:txBody>
-          <a:bodyPr/>
-          <a:lstStyle/>
-          <a:p>
-            <a:pPr lvl="0" indent="0" marL="0">
-              <a:buNone/>
-            </a:pPr>
-            <a:r>
-              <a:rPr b="1"/>
-              <a:t>Shown</a:t>
-            </a:r>
-          </a:p>
-          <a:p>
-            <a:pPr lvl="0"/>
-            <a:r>
-              <a:rPr b="1"/>
-              <a:t>[PROVED]</a:t>
-            </a:r>
-            <a:r>
-              <a:rPr/>
-              <a:t> the ratchet, for any score sequence</a:t>
-            </a:r>
-          </a:p>
-          <a:p>
-            <a:pPr lvl="0"/>
-            <a:r>
-              <a:rPr b="1"/>
-              <a:t>[MEASURED]</a:t>
-            </a:r>
-            <a:r>
-              <a:rPr/>
-              <a:t> its cost on two SKAB streams</a:t>
-            </a:r>
-          </a:p>
-          <a:p>
-            <a:pPr lvl="0"/>
-            <a:r>
-              <a:rPr b="1"/>
-              <a:t>[MEASURED]</a:t>
-            </a:r>
-            <a:r>
-              <a:rPr/>
-              <a:t> the scorer limit and recall saturation</a:t>
-            </a:r>
-          </a:p>
-          <a:p>
-            <a:pPr lvl="0"/>
-            <a:r>
-              <a:rPr b="1"/>
-              <a:t>[IMPLEMENTED]</a:t>
-            </a:r>
-            <a:r>
-              <a:rPr/>
-              <a:t> a tested four-action controller</a:t>
-            </a:r>
-          </a:p>
-          <a:p>
-            <a:pPr lvl="0"/>
-            <a:r>
-              <a:rPr b="1"/>
-              <a:t>[MEASURED]</a:t>
-            </a:r>
-            <a:r>
-              <a:rPr/>
-              <a:t> no harm on SKAB; a mapped failure set</a:t>
-            </a:r>
-          </a:p>
-        </p:txBody>
-      </p:sp>
-      <p:sp>
-        <p:nvSpPr>
-          <p:cNvPr id="4" name="Content Placeholder 3"/>
-          <p:cNvSpPr>
-            <a:spLocks noGrp="1"/>
-          </p:cNvSpPr>
-          <p:nvPr>
-            <p:ph idx="2" sz="half"/>
-          </p:nvPr>
-        </p:nvSpPr>
-        <p:spPr/>
-        <p:txBody>
-          <a:bodyPr/>
-          <a:lstStyle/>
-          <a:p>
-            <a:pPr lvl="0" indent="0" marL="0">
-              <a:buNone/>
-            </a:pPr>
-            <a:r>
-              <a:rPr b="1"/>
-              <a:t>Not shown</a:t>
-            </a:r>
-          </a:p>
-          <a:p>
-            <a:pPr lvl="0"/>
-            <a:r>
-              <a:rPr/>
-              <a:t>any benefit on real benign regime changes</a:t>
-            </a:r>
-          </a:p>
-          <a:p>
-            <a:pPr lvl="0"/>
-            <a:r>
-              <a:rPr/>
-              <a:t>any held-out or generalisation result</a:t>
-            </a:r>
-          </a:p>
-          <a:p>
-            <a:pPr lvl="0"/>
-            <a:r>
-              <a:rPr/>
-              <a:t>anything about </a:t>
-            </a:r>
-            <a:r>
-              <a:rPr>
-                <a:latin typeface="Courier"/>
-              </a:rPr>
-              <a:t>other/21.csv</a:t>
-            </a:r>
-            <a:r>
-              <a:rPr/>
-              <a:t>: reserved, never opened</a:t>
-            </a:r>
-          </a:p>
-          <a:p>
-            <a:pPr lvl="0" indent="0" marL="0">
-              <a:buNone/>
-            </a:pPr>
-            <a:r>
-              <a:rPr b="1"/>
-              <a:t>Limits:</a:t>
-            </a:r>
-            <a:r>
-              <a:rPr/>
-              <a:t> one event per stream, one channel (</a:t>
-            </a:r>
-            <a:r>
-              <a:rPr>
-                <a:latin typeface="Courier"/>
-              </a:rPr>
-              <a:t>Current</a:t>
-            </a:r>
-            <a:r>
-              <a:rPr/>
-              <a:t>), dataset licence not independently verified.</a:t>
-            </a:r>
-          </a:p>
-        </p:txBody>
-      </p:sp>
-    </p:spTree>
-  </p:cSld>
-</p:sld>
-</file>
-
 <file path=ppt/slides/slide14.xml><?xml version="1.0" encoding="utf-8"?>
 <p:sld xmlns:a="http://schemas.openxmlformats.org/drawingml/2006/main" xmlns:r="http://schemas.openxmlformats.org/officeDocument/2006/relationships" xmlns:p="http://schemas.openxmlformats.org/presentationml/2006/main">
   <p:cSld>
@@ -5315,7 +5229,7 @@
             </a:pPr>
             <a:r>
               <a:rPr/>
-              <a:t>The next experiment is designed to be able to kill the idea</a:t>
+              <a:t>The strongest case against us: a simpler rule is quieter</a:t>
             </a:r>
           </a:p>
         </p:txBody>
@@ -5334,6 +5248,184 @@
         <p:txBody>
           <a:bodyPr/>
           <a:lstStyle/>
+          <a:p>
+            <a:pPr lvl="0" indent="0" marL="0">
+              <a:buNone/>
+            </a:pPr>
+            <a:r>
+              <a:rPr b="1"/>
+              <a:t>These results do not establish a useful controller.</a:t>
+            </a:r>
+          </a:p>
+          <a:p>
+            <a:pPr lvl="0"/>
+            <a:r>
+              <a:rPr b="1"/>
+              <a:t>Admit-all is quieter on benign shifts:</a:t>
+            </a:r>
+            <a:r>
+              <a:rPr/>
+              <a:t> false-alert time 12 vs our 16 on Y1, and 28 vs our </a:t>
+            </a:r>
+            <a:r>
+              <a:rPr b="1"/>
+              <a:t>204</a:t>
+            </a:r>
+            <a:r>
+              <a:rPr/>
+              <a:t> on Y2.</a:t>
+            </a:r>
+          </a:p>
+          <a:p>
+            <a:pPr lvl="0"/>
+            <a:r>
+              <a:rPr b="1"/>
+              <a:t>Our only edge is keeping faults visible:</a:t>
+            </a:r>
+            <a:r>
+              <a:rPr/>
+              <a:t> on Y3 it alerts 0.29 of the fault against admit-all’s 0.04, both at recall 1/1.</a:t>
+            </a:r>
+          </a:p>
+          <a:p>
+            <a:pPr lvl="0"/>
+            <a:r>
+              <a:rPr b="1"/>
+              <a:t>SKAB gives no evidence either way:</a:t>
+            </a:r>
+            <a:r>
+              <a:rPr/>
+              <a:t> our rows are identical to fixed.</a:t>
+            </a:r>
+          </a:p>
+          <a:p>
+            <a:pPr lvl="0"/>
+            <a:r>
+              <a:rPr b="1"/>
+              <a:t>Abstention buys quiet with coverage:</a:t>
+            </a:r>
+            <a:r>
+              <a:rPr/>
+              <a:t> Sun et al. decide on 54/143 and 57/140 windows.</a:t>
+            </a:r>
+          </a:p>
+          <a:p>
+            <a:pPr lvl="0" indent="0" marL="0">
+              <a:buNone/>
+            </a:pPr>
+            <a:r>
+              <a:rPr b="1"/>
+              <a:t>What we claim instead:</a:t>
+            </a:r>
+            <a:r>
+              <a:rPr/>
+              <a:t> a proved mechanism, an honest negative-to-inconclusive development finding, and a test that can refute the direction.</a:t>
+            </a:r>
+          </a:p>
+        </p:txBody>
+      </p:sp>
+    </p:spTree>
+  </p:cSld>
+</p:sld>
+</file>
+
+<file path=ppt/slides/slide15.xml><?xml version="1.0" encoding="utf-8"?>
+<p:sld xmlns:a="http://schemas.openxmlformats.org/drawingml/2006/main" xmlns:r="http://schemas.openxmlformats.org/officeDocument/2006/relationships" xmlns:p="http://schemas.openxmlformats.org/presentationml/2006/main">
+  <p:cSld>
+    <p:spTree>
+      <p:nvGrpSpPr>
+        <p:cNvPr id="1" name=""/>
+        <p:cNvGrpSpPr/>
+        <p:nvPr/>
+      </p:nvGrpSpPr>
+      <p:grpSpPr>
+        <a:xfrm>
+          <a:off x="0" y="0"/>
+          <a:ext cx="0" cy="0"/>
+          <a:chOff x="0" y="0"/>
+          <a:chExt cx="0" cy="0"/>
+        </a:xfrm>
+      </p:grpSpPr>
+      <p:sp>
+        <p:nvSpPr>
+          <p:cNvPr id="2" name="Title 1"/>
+          <p:cNvSpPr>
+            <a:spLocks noGrp="1"/>
+          </p:cNvSpPr>
+          <p:nvPr>
+            <p:ph type="title"/>
+          </p:nvPr>
+        </p:nvSpPr>
+        <p:spPr/>
+        <p:txBody>
+          <a:bodyPr/>
+          <a:lstStyle/>
+          <a:p>
+            <a:pPr lvl="0" indent="0" marL="0">
+              <a:buNone/>
+            </a:pPr>
+            <a:r>
+              <a:rPr/>
+              <a:t>Not yet shown, and the experiment designed to kill the idea</a:t>
+            </a:r>
+          </a:p>
+        </p:txBody>
+      </p:sp>
+      <p:sp>
+        <p:nvSpPr>
+          <p:cNvPr id="3" name="Content Placeholder 2"/>
+          <p:cNvSpPr>
+            <a:spLocks noGrp="1"/>
+          </p:cNvSpPr>
+          <p:nvPr>
+            <p:ph idx="1"/>
+          </p:nvPr>
+        </p:nvSpPr>
+        <p:spPr/>
+        <p:txBody>
+          <a:bodyPr/>
+          <a:lstStyle/>
+          <a:p>
+            <a:pPr lvl="0" indent="0" marL="0">
+              <a:buNone/>
+            </a:pPr>
+            <a:r>
+              <a:rPr b="1"/>
+              <a:t>Not shown:</a:t>
+            </a:r>
+            <a:r>
+              <a:rPr/>
+              <a:t> any benefit on real benign regime changes; any held-out or generalisation result. </a:t>
+            </a:r>
+            <a:r>
+              <a:rPr b="1"/>
+              <a:t>Limits:</a:t>
+            </a:r>
+            <a:r>
+              <a:rPr/>
+              <a:t> one event per stream, one channel (</a:t>
+            </a:r>
+            <a:r>
+              <a:rPr>
+                <a:latin typeface="Courier"/>
+              </a:rPr>
+              <a:t>Current</a:t>
+            </a:r>
+            <a:r>
+              <a:rPr/>
+              <a:t>), dataset licence not independently verified; </a:t>
+            </a:r>
+            <a:r>
+              <a:rPr>
+                <a:latin typeface="Courier"/>
+              </a:rPr>
+              <a:t>other/21.csv</a:t>
+            </a:r>
+            <a:r>
+              <a:rPr/>
+              <a:t> reserved and never opened.</a:t>
+            </a:r>
+          </a:p>
           <a:p>
             <a:pPr lvl="0" indent="0" marL="0">
               <a:buNone/>
@@ -5344,7 +5436,7 @@
             </a:r>
             <a:r>
               <a:rPr/>
-              <a:t> Replay all arms on common traces over every other SKAB </a:t>
+              <a:t> Replay all policies on common traces over every other SKAB </a:t>
             </a:r>
             <a:r>
               <a:rPr>
@@ -5372,13 +5464,8 @@
             </a:r>
             <a:r>
               <a:rPr/>
-              <a:t> regime changes.</a:t>
-            </a:r>
-          </a:p>
-          <a:p>
-            <a:pPr lvl="0" indent="0" marL="0">
-              <a:buNone/>
-            </a:pPr>
+              <a:t> regime changes. </a:t>
+            </a:r>
             <a:r>
               <a:rPr b="1"/>
               <a:t>The direction is refuted if any one holds:</a:t>
@@ -5493,6 +5580,256 @@
             </a:pPr>
             <a:r>
               <a:rPr/>
+              <a:t>How alerting works: a score per window, a threshold, an operator</a:t>
+            </a:r>
+          </a:p>
+        </p:txBody>
+      </p:sp>
+      <p:sp>
+        <p:nvSpPr>
+          <p:cNvPr id="4" name="Text Placeholder 3"/>
+          <p:cNvSpPr>
+            <a:spLocks noGrp="1"/>
+          </p:cNvSpPr>
+          <p:nvPr>
+            <p:ph idx="2" sz="half" type="body"/>
+          </p:nvPr>
+        </p:nvSpPr>
+        <p:spPr/>
+        <p:txBody>
+          <a:bodyPr/>
+          <a:lstStyle/>
+          <a:p>
+            <a:pPr lvl="0" indent="0" marL="0">
+              <a:buNone/>
+            </a:pPr>
+            <a:r>
+              <a:rPr b="1"/>
+              <a:t>Our data:</a:t>
+            </a:r>
+            <a:r>
+              <a:rPr/>
+              <a:t> SKAB, a public benchmark recorded on a laboratory water-circulation rig. We use one sensor, the current drawn by its electric motor. </a:t>
+            </a:r>
+            <a:r>
+              <a:rPr b="1"/>
+              <a:t>Two ways to fail:</a:t>
+            </a:r>
+            <a:r>
+              <a:rPr/>
+              <a:t> miss a real fault, or raise false alerts. Each false alert costs an operator’s time; too many, and people stop trusting the alerts.</a:t>
+            </a:r>
+          </a:p>
+        </p:txBody>
+      </p:sp>
+      <p:pic>
+        <p:nvPicPr>
+          <p:cNvPr descr="figures/fig-basics.png" id="0" name="Picture 1"/>
+          <p:cNvPicPr>
+            <a:picLocks noGrp="1" noChangeAspect="1"/>
+          </p:cNvPicPr>
+          <p:nvPr/>
+        </p:nvPicPr>
+        <p:blipFill>
+          <a:blip r:embed="rId3"/>
+          <a:stretch>
+            <a:fillRect/>
+          </a:stretch>
+        </p:blipFill>
+        <p:spPr bwMode="auto">
+          <a:xfrm>
+            <a:off x="3568700" y="1409700"/>
+            <a:ext cx="5105400" cy="1955800"/>
+          </a:xfrm>
+          <a:prstGeom prst="rect">
+            <a:avLst/>
+          </a:prstGeom>
+          <a:noFill/>
+          <a:ln w="9525">
+            <a:noFill/>
+            <a:headEnd/>
+            <a:tailEnd/>
+          </a:ln>
+        </p:spPr>
+      </p:pic>
+    </p:spTree>
+  </p:cSld>
+</p:sld>
+</file>
+
+<file path=ppt/slides/slide3.xml><?xml version="1.0" encoding="utf-8"?>
+<p:sld xmlns:a="http://schemas.openxmlformats.org/drawingml/2006/main" xmlns:r="http://schemas.openxmlformats.org/officeDocument/2006/relationships" xmlns:p="http://schemas.openxmlformats.org/presentationml/2006/main">
+  <p:cSld>
+    <p:spTree>
+      <p:nvGrpSpPr>
+        <p:cNvPr id="1" name=""/>
+        <p:cNvGrpSpPr/>
+        <p:nvPr/>
+      </p:nvGrpSpPr>
+      <p:grpSpPr>
+        <a:xfrm>
+          <a:off x="0" y="0"/>
+          <a:ext cx="0" cy="0"/>
+          <a:chOff x="0" y="0"/>
+          <a:chExt cx="0" cy="0"/>
+        </a:xfrm>
+      </p:grpSpPr>
+      <p:sp>
+        <p:nvSpPr>
+          <p:cNvPr id="2" name="Title 1"/>
+          <p:cNvSpPr>
+            <a:spLocks noGrp="1"/>
+          </p:cNvSpPr>
+          <p:nvPr>
+            <p:ph type="title"/>
+          </p:nvPr>
+        </p:nvSpPr>
+        <p:spPr>
+          <a:xfrm>
+            <a:off x="457201" y="204787"/>
+            <a:ext cx="3008313" cy="871538"/>
+          </a:xfrm>
+        </p:spPr>
+        <p:txBody>
+          <a:bodyPr/>
+          <a:lstStyle/>
+          <a:p>
+            <a:pPr lvl="0" indent="0" marL="0">
+              <a:buNone/>
+            </a:pPr>
+            <a:r>
+              <a:rPr/>
+              <a:t>Normal drifts, so thresholds learn, but from which windows?</a:t>
+            </a:r>
+          </a:p>
+        </p:txBody>
+      </p:sp>
+      <p:sp>
+        <p:nvSpPr>
+          <p:cNvPr id="4" name="Text Placeholder 3"/>
+          <p:cNvSpPr>
+            <a:spLocks noGrp="1"/>
+          </p:cNvSpPr>
+          <p:nvPr>
+            <p:ph idx="2" sz="half" type="body"/>
+          </p:nvPr>
+        </p:nvSpPr>
+        <p:spPr/>
+        <p:txBody>
+          <a:bodyPr/>
+          <a:lstStyle/>
+          <a:p>
+            <a:pPr lvl="0" indent="0" marL="0">
+              <a:buNone/>
+            </a:pPr>
+            <a:r>
+              <a:rPr/>
+              <a:t>When normal </a:t>
+            </a:r>
+            <a:r>
+              <a:rPr b="1"/>
+              <a:t>shifts up</a:t>
+            </a:r>
+            <a:r>
+              <a:rPr/>
+              <a:t> (a repair, a new load), a fixed threshold floods the operator with false alerts, so systems </a:t>
+            </a:r>
+            <a:r>
+              <a:rPr b="1"/>
+              <a:t>recalibrate</a:t>
+            </a:r>
+            <a:r>
+              <a:rPr/>
+              <a:t>: they re-set the threshold from recent scores. </a:t>
+            </a:r>
+            <a:r>
+              <a:rPr b="1"/>
+              <a:t>Which windows should it learn from?</a:t>
+            </a:r>
+            <a:r>
+              <a:rPr/>
+              <a:t> The two obvious answers both fail.</a:t>
+            </a:r>
+          </a:p>
+        </p:txBody>
+      </p:sp>
+      <p:pic>
+        <p:nvPicPr>
+          <p:cNvPr descr="figures/fig-dilemma.png" id="0" name="Picture 1"/>
+          <p:cNvPicPr>
+            <a:picLocks noGrp="1" noChangeAspect="1"/>
+          </p:cNvPicPr>
+          <p:nvPr/>
+        </p:nvPicPr>
+        <p:blipFill>
+          <a:blip r:embed="rId3"/>
+          <a:stretch>
+            <a:fillRect/>
+          </a:stretch>
+        </p:blipFill>
+        <p:spPr bwMode="auto">
+          <a:xfrm>
+            <a:off x="3568700" y="1460500"/>
+            <a:ext cx="5105400" cy="1866900"/>
+          </a:xfrm>
+          <a:prstGeom prst="rect">
+            <a:avLst/>
+          </a:prstGeom>
+          <a:noFill/>
+          <a:ln w="9525">
+            <a:noFill/>
+            <a:headEnd/>
+            <a:tailEnd/>
+          </a:ln>
+        </p:spPr>
+      </p:pic>
+    </p:spTree>
+  </p:cSld>
+</p:sld>
+</file>
+
+<file path=ppt/slides/slide4.xml><?xml version="1.0" encoding="utf-8"?>
+<p:sld xmlns:a="http://schemas.openxmlformats.org/drawingml/2006/main" xmlns:r="http://schemas.openxmlformats.org/officeDocument/2006/relationships" xmlns:p="http://schemas.openxmlformats.org/presentationml/2006/main">
+  <p:cSld>
+    <p:spTree>
+      <p:nvGrpSpPr>
+        <p:cNvPr id="1" name=""/>
+        <p:cNvGrpSpPr/>
+        <p:nvPr/>
+      </p:nvGrpSpPr>
+      <p:grpSpPr>
+        <a:xfrm>
+          <a:off x="0" y="0"/>
+          <a:ext cx="0" cy="0"/>
+          <a:chOff x="0" y="0"/>
+          <a:chExt cx="0" cy="0"/>
+        </a:xfrm>
+      </p:grpSpPr>
+      <p:sp>
+        <p:nvSpPr>
+          <p:cNvPr id="2" name="Title 1"/>
+          <p:cNvSpPr>
+            <a:spLocks noGrp="1"/>
+          </p:cNvSpPr>
+          <p:nvPr>
+            <p:ph type="title"/>
+          </p:nvPr>
+        </p:nvSpPr>
+        <p:spPr>
+          <a:xfrm>
+            <a:off x="457201" y="204787"/>
+            <a:ext cx="3008313" cy="871538"/>
+          </a:xfrm>
+        </p:spPr>
+        <p:txBody>
+          <a:bodyPr/>
+          <a:lstStyle/>
+          <a:p>
+            <a:pPr lvl="0" indent="0" marL="0">
+              <a:buNone/>
+            </a:pPr>
+            <a:r>
+              <a:rPr/>
               <a:t>A threshold that learns only from “normal” windows can only fall</a:t>
             </a:r>
           </a:p>
@@ -5526,15 +5863,7 @@
             </a:r>
             <a:r>
               <a:rPr/>
-              <a:t>. Score 9 is normal at step 1 and an alert at step 6: the alerts come from the threshold, not the signal. Admitting </a:t>
-            </a:r>
-            <a:r>
-              <a:rPr i="1"/>
-              <a:t>every</a:t>
-            </a:r>
-            <a:r>
-              <a:rPr/>
-              <a:t> score fails the other way, because a sustained fault becomes the new normal.</a:t>
+              <a:t>. Score 9 is normal at step 1 and an alert at step 6: the alerts come from the threshold, not the signal.</a:t>
             </a:r>
           </a:p>
         </p:txBody>
@@ -6123,10 +6452,10 @@
 </p:sld>
 </file>
 
-<file path=ppt/slides/slide3.xml><?xml version="1.0" encoding="UTF-8"?><p:sld xmlns:a="http://schemas.openxmlformats.org/drawingml/2006/main" xmlns:r="http://schemas.openxmlformats.org/officeDocument/2006/relationships" xmlns:p="http://schemas.openxmlformats.org/presentationml/2006/main"><p:cSld><p:spTree><p:nvGrpSpPr><p:cNvPr id="1" name="" /><p:cNvGrpSpPr /><p:nvPr /></p:nvGrpSpPr><p:grpSpPr><a:xfrm><a:off x="0" y="0" /><a:ext cx="0" cy="0" /><a:chOff x="0" y="0" /><a:chExt cx="0" cy="0" /></a:xfrm></p:grpSpPr><p:sp><p:nvSpPr><p:cNvPr id="2" name="Title 1" /><p:cNvSpPr><a:spLocks noGrp="1" /></p:cNvSpPr><p:nvPr><p:ph type="title" /></p:nvPr></p:nvSpPr><p:spPr><a:xfrm><a:off x="457201" y="204787" /><a:ext cx="3008313" cy="871538" /></a:xfrm></p:spPr><p:txBody><a:bodyPr /><a:lstStyle /><a:p><a:pPr lvl="0" indent="0" marL="0"><a:buNone /></a:pPr><a:r><a:rPr /><a:t>Our direction: recalibration as a guarded, auditable action</a:t></a:r></a:p></p:txBody></p:sp><p:sp><p:nvSpPr><p:cNvPr id="4" name="Text Placeholder 3" /><p:cNvSpPr><a:spLocks noGrp="1" /></p:cNvSpPr><p:nvPr><p:ph idx="2" sz="half" type="body" /></p:nvPr></p:nvSpPr><p:spPr /><p:txBody><a:bodyPr /><a:lstStyle /><a:p><a:pPr lvl="0" indent="0" marL="0"><a:buNone /></a:pPr><a:r><a:rPr /><a:t>Recalibrate only as a deliberate decision, from data chosen </a:t></a:r><a:r><a:rPr b="1" /><a:t>neither by the threshold itself nor unconditionally</a:t></a:r><a:r><a:rPr /><a:t>, and judge every option on </a:t></a:r><a:r><a:rPr b="1" /><a:t>one common score trace</a:t></a:r><a:r><a:rPr /><a:t>.</a:t></a:r></a:p></p:txBody></p:sp><p:graphicFrame><p:nvGraphicFramePr><p:cNvPr id="6" name="Content Placeholder 5" /><p:cNvGraphicFramePr><a:graphicFrameLocks noGrp="1" /></p:cNvGraphicFramePr><p:nvPr><p:ph idx="1" /></p:nvPr></p:nvGraphicFramePr><p:xfrm><a:off x="3568700" y="203200" /><a:ext cx="5105400" cy="4381500" /></p:xfrm><a:graphic><a:graphicData uri="http://schemas.openxmlformats.org/drawingml/2006/table"><a:tbl><a:tblPr firstRow="1" bandRow="1"><a:tableStyleId>{5C22544A-7EE6-4342-B048-85BDC9FD1C3A}</a:tableStyleId></a:tblPr><a:tblGrid><a:gridCol w="965200" /><a:gridCol w="4140200" /></a:tblGrid><a:tr h="0"><a:tc><a:txBody><a:bodyPr /><a:lstStyle /><a:p><a:pPr lvl="0" indent="0" marL="0" algn="l"><a:buNone /></a:pPr><a:r><a:rPr /><a:t>Evidence</a:t></a:r></a:p></a:txBody><a:tcPr /></a:tc><a:tc><a:txBody><a:bodyPr /><a:lstStyle /><a:p><a:pPr lvl="0" indent="0" marL="0" algn="l"><a:buNone /></a:pPr><a:r><a:rPr /><a:t>What we claim</a:t></a:r></a:p></a:txBody><a:tcPr /></a:tc></a:tr><a:tr h="0"><a:tc><a:txBody><a:bodyPr /><a:lstStyle /><a:p><a:pPr lvl="0" indent="0" marL="0" algn="l"><a:buNone /></a:pPr><a:r><a:rPr b="1" /><a:t>[PROVED]</a:t></a:r></a:p></a:txBody></a:tc><a:tc><a:txBody><a:bodyPr /><a:lstStyle /><a:p><a:pPr lvl="0" indent="0" marL="0" algn="l"><a:buNone /></a:pPr><a:r><a:rPr /><a:t>C1: learning only from “normal” windows means the threshold never rises</a:t></a:r></a:p></a:txBody></a:tc></a:tr><a:tr h="0"><a:tc><a:txBody><a:bodyPr /><a:lstStyle /><a:p><a:pPr lvl="0" indent="0" marL="0" algn="l"><a:buNone /></a:pPr><a:r><a:rPr b="1" /><a:t>[MEASURED]</a:t></a:r></a:p></a:txBody></a:tc><a:tc><a:txBody><a:bodyPr /><a:lstStyle /><a:p><a:pPr lvl="0" indent="0" marL="0" algn="l"><a:buNone /></a:pPr><a:r><a:rPr /><a:t>C2: on SKAB that costs 16.2× and 3.9× the alert windows</a:t></a:r></a:p></a:txBody></a:tc></a:tr><a:tr h="0"><a:tc><a:txBody><a:bodyPr /><a:lstStyle /><a:p><a:pPr lvl="0" indent="0" marL="0" algn="l"><a:buNone /></a:pPr><a:r><a:rPr b="1" /><a:t>[MEASURED]</a:t></a:r></a:p></a:txBody></a:tc><a:tc><a:txBody><a:bodyPr /><a:lstStyle /><a:p><a:pPr lvl="0" indent="0" marL="0" algn="l"><a:buNone /></a:pPr><a:r><a:rPr /><a:t>C3: the scorer, not the policy, limits detection</a:t></a:r></a:p></a:txBody></a:tc></a:tr><a:tr h="0"><a:tc><a:txBody><a:bodyPr /><a:lstStyle /><a:p><a:pPr lvl="0" indent="0" marL="0" algn="l"><a:buNone /></a:pPr><a:r><a:rPr b="1" /><a:t>[IMPLEMENTED]</a:t></a:r></a:p></a:txBody></a:tc><a:tc><a:txBody><a:bodyPr /><a:lstStyle /><a:p><a:pPr lvl="0" indent="0" marL="0" algn="l"><a:buNone /></a:pPr><a:r><a:rPr /><a:t>C4: a four-action controller, recalibration bounded to </a:t></a:r><a14:m><m:oMath xmlns:m="http://schemas.openxmlformats.org/officeDocument/2006/math"><m:r><m:rPr><m:sty m:val="p" /></m:rPr><m:t>[</m:t></m:r><m:sSub><m:e><m:r><m:t>θ</m:t></m:r></m:e><m:sub><m:r><m:t>0</m:t></m:r></m:sub></m:sSub><m:r><m:rPr><m:sty m:val="p" /></m:rPr><m:t>,</m:t></m:r><m:r><m:t>4</m:t></m:r><m:sSub><m:e><m:r><m:t>θ</m:t></m:r></m:e><m:sub><m:r><m:t>0</m:t></m:r></m:sub></m:sSub><m:r><m:rPr><m:sty m:val="p" /></m:rPr><m:t>]</m:t></m:r></m:oMath></a14:m></a:p></a:txBody></a:tc></a:tr><a:tr h="0"><a:tc><a:txBody><a:bodyPr /><a:lstStyle /><a:p><a:pPr lvl="0" indent="0" marL="0" algn="l"><a:buNone /></a:pPr><a:r><a:rPr b="1" /><a:t>[MEASURED]</a:t></a:r></a:p></a:txBody></a:tc><a:tc><a:txBody><a:bodyPr /><a:lstStyle /><a:p><a:pPr lvl="0" indent="0" marL="0" algn="l"><a:buNone /></a:pPr><a:r><a:rPr /><a:t>C5: identical to fixed on SKAB, so no harm and no benefit</a:t></a:r></a:p></a:txBody></a:tc></a:tr><a:tr h="0"><a:tc><a:txBody><a:bodyPr /><a:lstStyle /><a:p><a:pPr lvl="0" indent="0" marL="0" algn="l"><a:buNone /></a:pPr><a:r><a:rPr b="1" /><a:t>[MEASURED]</a:t></a:r></a:p></a:txBody></a:tc><a:tc><a:txBody><a:bodyPr /><a:lstStyle /><a:p><a:pPr lvl="0" indent="0" marL="0" algn="l"><a:buNone /></a:pPr><a:r><a:rPr /><a:t>C6: under stress it works on a step and fails on a ramp</a:t></a:r></a:p></a:txBody></a:tc></a:tr><a:tr h="0"><a:tc><a:txBody><a:bodyPr /><a:lstStyle /><a:p><a:pPr lvl="0" indent="0" marL="0" algn="l"><a:buNone /></a:pPr><a:r><a:rPr b="1" /><a:t>[PROPOSED]</a:t></a:r></a:p></a:txBody></a:tc><a:tc><a:txBody><a:bodyPr /><a:lstStyle /><a:p><a:pPr lvl="0" indent="0" marL="0" algn="l"><a:buNone /></a:pPr><a:r><a:rPr /><a:t>C7: a benefit on real regime changes, decided by a kill test</a:t></a:r></a:p></a:txBody></a:tc></a:tr></a:tbl></a:graphicData></a:graphic></p:graphicFrame></p:spTree></p:cSld></p:sld>
+<file path=ppt/slides/slide5.xml><?xml version="1.0" encoding="UTF-8"?><p:sld xmlns:a="http://schemas.openxmlformats.org/drawingml/2006/main" xmlns:r="http://schemas.openxmlformats.org/officeDocument/2006/relationships" xmlns:p="http://schemas.openxmlformats.org/presentationml/2006/main"><p:cSld><p:spTree><p:nvGrpSpPr><p:cNvPr id="1" name="" /><p:cNvGrpSpPr /><p:nvPr /></p:nvGrpSpPr><p:grpSpPr><a:xfrm><a:off x="0" y="0" /><a:ext cx="0" cy="0" /><a:chOff x="0" y="0" /><a:chExt cx="0" cy="0" /></a:xfrm></p:grpSpPr><p:sp><p:nvSpPr><p:cNvPr id="2" name="Title 1" /><p:cNvSpPr><a:spLocks noGrp="1" /></p:cNvSpPr><p:nvPr><p:ph type="title" /></p:nvPr></p:nvSpPr><p:spPr><a:xfrm><a:off x="457201" y="204787" /><a:ext cx="3008313" cy="871538" /></a:xfrm></p:spPr><p:txBody><a:bodyPr /><a:lstStyle /><a:p><a:pPr lvl="0" indent="0" marL="0"><a:buNone /></a:pPr><a:r><a:rPr /><a:t>Our direction: recalibration as a guarded, auditable action</a:t></a:r></a:p></p:txBody></p:sp><p:sp><p:nvSpPr><p:cNvPr id="4" name="Text Placeholder 3" /><p:cNvSpPr><a:spLocks noGrp="1" /></p:cNvSpPr><p:nvPr><p:ph idx="2" sz="half" type="body" /></p:nvPr></p:nvSpPr><p:spPr /><p:txBody><a:bodyPr /><a:lstStyle /><a:p><a:pPr lvl="0" indent="0" marL="0"><a:buNone /></a:pPr><a:r><a:rPr /><a:t>Recalibrate only as a deliberate decision, from data chosen </a:t></a:r><a:r><a:rPr b="1" /><a:t>neither by the threshold itself nor unconditionally</a:t></a:r><a:r><a:rPr /><a:t>, and judge every policy on </a:t></a:r><a:r><a:rPr b="1" /><a:t>identical scores</a:t></a:r><a:r><a:rPr /><a:t>. Tags: PROVED = theorem · MEASURED = saved, recomputed result · IMPLEMENTED = tested code · PROPOSED = not yet tested.</a:t></a:r></a:p></p:txBody></p:sp><p:graphicFrame><p:nvGraphicFramePr><p:cNvPr id="6" name="Content Placeholder 5" /><p:cNvGraphicFramePr><a:graphicFrameLocks noGrp="1" /></p:cNvGraphicFramePr><p:nvPr><p:ph idx="1" /></p:nvPr></p:nvGraphicFramePr><p:xfrm><a:off x="3568700" y="203200" /><a:ext cx="5105400" cy="4381500" /></p:xfrm><a:graphic><a:graphicData uri="http://schemas.openxmlformats.org/drawingml/2006/table"><a:tbl><a:tblPr firstRow="1" bandRow="1"><a:tableStyleId>{5C22544A-7EE6-4342-B048-85BDC9FD1C3A}</a:tableStyleId></a:tblPr><a:tblGrid><a:gridCol w="965200" /><a:gridCol w="4140200" /></a:tblGrid><a:tr h="0"><a:tc><a:txBody><a:bodyPr /><a:lstStyle /><a:p><a:pPr lvl="0" indent="0" marL="0" algn="l"><a:buNone /></a:pPr><a:r><a:rPr /><a:t>Evidence</a:t></a:r></a:p></a:txBody><a:tcPr /></a:tc><a:tc><a:txBody><a:bodyPr /><a:lstStyle /><a:p><a:pPr lvl="0" indent="0" marL="0" algn="l"><a:buNone /></a:pPr><a:r><a:rPr /><a:t>What we claim</a:t></a:r></a:p></a:txBody><a:tcPr /></a:tc></a:tr><a:tr h="0"><a:tc><a:txBody><a:bodyPr /><a:lstStyle /><a:p><a:pPr lvl="0" indent="0" marL="0" algn="l"><a:buNone /></a:pPr><a:r><a:rPr b="1" /><a:t>[PROVED]</a:t></a:r></a:p></a:txBody></a:tc><a:tc><a:txBody><a:bodyPr /><a:lstStyle /><a:p><a:pPr lvl="0" indent="0" marL="0" algn="l"><a:buNone /></a:pPr><a:r><a:rPr /><a:t>C1: learning only from “normal” windows means the threshold never rises</a:t></a:r></a:p></a:txBody></a:tc></a:tr><a:tr h="0"><a:tc><a:txBody><a:bodyPr /><a:lstStyle /><a:p><a:pPr lvl="0" indent="0" marL="0" algn="l"><a:buNone /></a:pPr><a:r><a:rPr b="1" /><a:t>[MEASURED]</a:t></a:r></a:p></a:txBody></a:tc><a:tc><a:txBody><a:bodyPr /><a:lstStyle /><a:p><a:pPr lvl="0" indent="0" marL="0" algn="l"><a:buNone /></a:pPr><a:r><a:rPr /><a:t>C2: on SKAB that costs 16.2× and 3.9× the alert windows</a:t></a:r></a:p></a:txBody></a:tc></a:tr><a:tr h="0"><a:tc><a:txBody><a:bodyPr /><a:lstStyle /><a:p><a:pPr lvl="0" indent="0" marL="0" algn="l"><a:buNone /></a:pPr><a:r><a:rPr b="1" /><a:t>[MEASURED]</a:t></a:r></a:p></a:txBody></a:tc><a:tc><a:txBody><a:bodyPr /><a:lstStyle /><a:p><a:pPr lvl="0" indent="0" marL="0" algn="l"><a:buNone /></a:pPr><a:r><a:rPr /><a:t>C3: the scorer, not the policy, limits detection</a:t></a:r></a:p></a:txBody></a:tc></a:tr><a:tr h="0"><a:tc><a:txBody><a:bodyPr /><a:lstStyle /><a:p><a:pPr lvl="0" indent="0" marL="0" algn="l"><a:buNone /></a:pPr><a:r><a:rPr b="1" /><a:t>[IMPLEMENTED]</a:t></a:r></a:p></a:txBody></a:tc><a:tc><a:txBody><a:bodyPr /><a:lstStyle /><a:p><a:pPr lvl="0" indent="0" marL="0" algn="l"><a:buNone /></a:pPr><a:r><a:rPr /><a:t>C4: a four-action controller, recalibration bounded to </a:t></a:r><a14:m><m:oMath xmlns:m="http://schemas.openxmlformats.org/officeDocument/2006/math"><m:r><m:rPr><m:sty m:val="p" /></m:rPr><m:t>[</m:t></m:r><m:sSub><m:e><m:r><m:t>θ</m:t></m:r></m:e><m:sub><m:r><m:t>0</m:t></m:r></m:sub></m:sSub><m:r><m:rPr><m:sty m:val="p" /></m:rPr><m:t>,</m:t></m:r><m:r><m:t>4</m:t></m:r><m:sSub><m:e><m:r><m:t>θ</m:t></m:r></m:e><m:sub><m:r><m:t>0</m:t></m:r></m:sub></m:sSub><m:r><m:rPr><m:sty m:val="p" /></m:rPr><m:t>]</m:t></m:r></m:oMath></a14:m></a:p></a:txBody></a:tc></a:tr><a:tr h="0"><a:tc><a:txBody><a:bodyPr /><a:lstStyle /><a:p><a:pPr lvl="0" indent="0" marL="0" algn="l"><a:buNone /></a:pPr><a:r><a:rPr b="1" /><a:t>[MEASURED]</a:t></a:r></a:p></a:txBody></a:tc><a:tc><a:txBody><a:bodyPr /><a:lstStyle /><a:p><a:pPr lvl="0" indent="0" marL="0" algn="l"><a:buNone /></a:pPr><a:r><a:rPr /><a:t>C5: identical to fixed on SKAB, so no harm and no benefit</a:t></a:r></a:p></a:txBody></a:tc></a:tr><a:tr h="0"><a:tc><a:txBody><a:bodyPr /><a:lstStyle /><a:p><a:pPr lvl="0" indent="0" marL="0" algn="l"><a:buNone /></a:pPr><a:r><a:rPr b="1" /><a:t>[MEASURED]</a:t></a:r></a:p></a:txBody></a:tc><a:tc><a:txBody><a:bodyPr /><a:lstStyle /><a:p><a:pPr lvl="0" indent="0" marL="0" algn="l"><a:buNone /></a:pPr><a:r><a:rPr /><a:t>C6: under stress it works on a step and fails on a ramp</a:t></a:r></a:p></a:txBody></a:tc></a:tr><a:tr h="0"><a:tc><a:txBody><a:bodyPr /><a:lstStyle /><a:p><a:pPr lvl="0" indent="0" marL="0" algn="l"><a:buNone /></a:pPr><a:r><a:rPr b="1" /><a:t>[PROPOSED]</a:t></a:r></a:p></a:txBody></a:tc><a:tc><a:txBody><a:bodyPr /><a:lstStyle /><a:p><a:pPr lvl="0" indent="0" marL="0" algn="l"><a:buNone /></a:pPr><a:r><a:rPr /><a:t>C7: a benefit on real regime changes, decided by a kill test</a:t></a:r></a:p></a:txBody></a:tc></a:tr></a:tbl></a:graphicData></a:graphic></p:graphicFrame></p:spTree></p:cSld></p:sld>
 </file>
 
-<file path=ppt/slides/slide4.xml><?xml version="1.0" encoding="utf-8"?>
+<file path=ppt/slides/slide6.xml><?xml version="1.0" encoding="utf-8"?>
 <p:sld xmlns:a="http://schemas.openxmlformats.org/drawingml/2006/main" xmlns:r="http://schemas.openxmlformats.org/officeDocument/2006/relationships" xmlns:p="http://schemas.openxmlformats.org/presentationml/2006/main">
   <p:cSld>
     <p:spTree>
@@ -6568,7 +6897,7 @@
 </p:sld>
 </file>
 
-<file path=ppt/slides/slide5.xml><?xml version="1.0" encoding="utf-8"?>
+<file path=ppt/slides/slide7.xml><?xml version="1.0" encoding="utf-8"?>
 <p:sld xmlns:a="http://schemas.openxmlformats.org/drawingml/2006/main" xmlns:r="http://schemas.openxmlformats.org/officeDocument/2006/relationships" xmlns:p="http://schemas.openxmlformats.org/presentationml/2006/main">
   <p:cSld>
     <p:spTree>
@@ -6645,7 +6974,7 @@
 </p:sld>
 </file>
 
-<file path=ppt/slides/slide6.xml><?xml version="1.0" encoding="utf-8"?>
+<file path=ppt/slides/slide8.xml><?xml version="1.0" encoding="utf-8"?>
 <p:sld xmlns:a="http://schemas.openxmlformats.org/drawingml/2006/main" xmlns:r="http://schemas.openxmlformats.org/officeDocument/2006/relationships" xmlns:p="http://schemas.openxmlformats.org/presentationml/2006/main">
   <p:cSld>
     <p:spTree>
@@ -6889,7 +7218,7 @@
 </p:sld>
 </file>
 
-<file path=ppt/slides/slide7.xml><?xml version="1.0" encoding="utf-8"?>
+<file path=ppt/slides/slide9.xml><?xml version="1.0" encoding="utf-8"?>
 <p:sld xmlns:a="http://schemas.openxmlformats.org/drawingml/2006/main" xmlns:r="http://schemas.openxmlformats.org/officeDocument/2006/relationships" xmlns:p="http://schemas.openxmlformats.org/presentationml/2006/main">
   <p:cSld>
     <p:spTree>
@@ -6976,7 +7305,23 @@
             </a:r>
             <a:r>
               <a:rPr/>
-              <a:t> = alerted samples outside the labelled event.</a:t>
+              <a:t> = alerted samples outside the event · </a:t>
+            </a:r>
+            <a:r>
+              <a:rPr i="1"/>
+              <a:t>recall</a:t>
+            </a:r>
+            <a:r>
+              <a:rPr/>
+              <a:t> = events caught · </a:t>
+            </a:r>
+            <a:r>
+              <a:rPr i="1"/>
+              <a:t>coverage</a:t>
+            </a:r>
+            <a:r>
+              <a:rPr/>
+              <a:t> = windows decided rather than deferred.</a:t>
             </a:r>
           </a:p>
         </p:txBody>
@@ -7019,7 +7364,7 @@
                       </a:pPr>
                       <a:r>
                         <a:rPr/>
-                        <a:t>Arm (valve1 / valve2)</a:t>
+                        <a:t>Policy (valve1 / valve2)</a:t>
                       </a:r>
                     </a:p>
                   </a:txBody>
@@ -7559,180 +7904,6 @@
     </p:spTree>
   </p:cSld>
 </p:sld>
-</file>
-
-<file path=ppt/slides/slide8.xml><?xml version="1.0" encoding="utf-8"?>
-<p:sld xmlns:a="http://schemas.openxmlformats.org/drawingml/2006/main" xmlns:r="http://schemas.openxmlformats.org/officeDocument/2006/relationships" xmlns:p="http://schemas.openxmlformats.org/presentationml/2006/main">
-  <p:cSld>
-    <p:spTree>
-      <p:nvGrpSpPr>
-        <p:cNvPr id="1" name=""/>
-        <p:cNvGrpSpPr/>
-        <p:nvPr/>
-      </p:nvGrpSpPr>
-      <p:grpSpPr>
-        <a:xfrm>
-          <a:off x="0" y="0"/>
-          <a:ext cx="0" cy="0"/>
-          <a:chOff x="0" y="0"/>
-          <a:chExt cx="0" cy="0"/>
-        </a:xfrm>
-      </p:grpSpPr>
-      <p:sp>
-        <p:nvSpPr>
-          <p:cNvPr id="2" name="Title 1"/>
-          <p:cNvSpPr>
-            <a:spLocks noGrp="1"/>
-          </p:cNvSpPr>
-          <p:nvPr>
-            <p:ph type="title"/>
-          </p:nvPr>
-        </p:nvSpPr>
-        <p:spPr>
-          <a:xfrm>
-            <a:off x="457201" y="204787"/>
-            <a:ext cx="3008313" cy="871538"/>
-          </a:xfrm>
-        </p:spPr>
-        <p:txBody>
-          <a:bodyPr/>
-          <a:lstStyle/>
-          <a:p>
-            <a:pPr lvl="0" indent="0" marL="0">
-              <a:buNone/>
-            </a:pPr>
-            <a:r>
-              <a:rPr/>
-              <a:t>The scorer, not the policy, limits detection on SKAB</a:t>
-            </a:r>
-          </a:p>
-        </p:txBody>
-      </p:sp>
-      <mc:AlternateContent xmlns:mc="http://schemas.openxmlformats.org/markup-compatibility/2006">
-        <mc:Choice xmlns:a14="http://schemas.microsoft.com/office/drawing/2010/main" Requires="a14">
-          <p:sp>
-            <p:nvSpPr>
-              <p:cNvPr id="4" name="Text Placeholder 3"/>
-              <p:cNvSpPr>
-                <a:spLocks noGrp="1"/>
-              </p:cNvSpPr>
-              <p:nvPr>
-                <p:ph idx="2" sz="half" type="body"/>
-              </p:nvPr>
-            </p:nvSpPr>
-            <p:spPr/>
-            <p:txBody>
-              <a:bodyPr/>
-              <a:lstStyle/>
-              <a:p>
-                <a:pPr lvl="0" indent="0" marL="0">
-                  <a:buNone/>
-                </a:pPr>
-                <a:r>
-                  <a:rPr b="1"/>
-                  <a:t>[MEASURED]</a:t>
-                </a:r>
-                <a:r>
-                  <a:rPr/>
-                  <a:t> Only </a:t>
-                </a:r>
-                <a:r>
-                  <a:rPr b="1"/>
-                  <a:t>6/100</a:t>
-                </a:r>
-                <a:r>
-                  <a:rPr/>
-                  <a:t> (valve1) and </a:t>
-                </a:r>
-                <a:r>
-                  <a:rPr b="1"/>
-                  <a:t>13/98</a:t>
-                </a:r>
-                <a:r>
-                  <a:rPr/>
-                  <a:t> (valve2) in-event windows exceed </a:t>
-                </a:r>
-                <a14:m>
-                  <m:oMath xmlns:m="http://schemas.openxmlformats.org/officeDocument/2006/math">
-                    <m:sSub>
-                      <m:e>
-                        <m:r>
-                          <m:t>θ</m:t>
-                        </m:r>
-                      </m:e>
-                      <m:sub>
-                        <m:r>
-                          <m:t>0</m:t>
-                        </m:r>
-                      </m:sub>
-                    </m:sSub>
-                  </m:oMath>
-                </a14:m>
-                <a:r>
-                  <a:rPr/>
-                  <a:t>, never more than </a:t>
-                </a:r>
-                <a:r>
-                  <a:rPr b="1"/>
-                  <a:t>2</a:t>
-                </a:r>
-                <a:r>
-                  <a:rPr/>
-                  <a:t> in a row, so rules needing 3 miss the events. Each event spans about </a:t>
-                </a:r>
-                <a:r>
-                  <a:rPr b="1"/>
-                  <a:t>70%</a:t>
-                </a:r>
-                <a:r>
-                  <a:rPr/>
-                  <a:t> of replay, so recall 1/1 says little. </a:t>
-                </a:r>
-                <a:r>
-                  <a:rPr b="1"/>
-                  <a:t>A policy can move alerts in time; it cannot create separation the scorer lacks.</a:t>
-                </a:r>
-              </a:p>
-            </p:txBody>
-          </p:sp>
-        </mc:Choice>
-      </mc:AlternateContent>
-      <p:pic>
-        <p:nvPicPr>
-          <p:cNvPr descr="figures/fig-scorer-limit.png" id="0" name="Picture 1"/>
-          <p:cNvPicPr>
-            <a:picLocks noGrp="1" noChangeAspect="1"/>
-          </p:cNvPicPr>
-          <p:nvPr/>
-        </p:nvPicPr>
-        <p:blipFill>
-          <a:blip r:embed="rId3"/>
-          <a:stretch>
-            <a:fillRect/>
-          </a:stretch>
-        </p:blipFill>
-        <p:spPr bwMode="auto">
-          <a:xfrm>
-            <a:off x="3568700" y="1447800"/>
-            <a:ext cx="5105400" cy="1879600"/>
-          </a:xfrm>
-          <a:prstGeom prst="rect">
-            <a:avLst/>
-          </a:prstGeom>
-          <a:noFill/>
-          <a:ln w="9525">
-            <a:noFill/>
-            <a:headEnd/>
-            <a:tailEnd/>
-          </a:ln>
-        </p:spPr>
-      </p:pic>
-    </p:spTree>
-  </p:cSld>
-</p:sld>
-</file>
-
-<file path=ppt/slides/slide9.xml><?xml version="1.0" encoding="UTF-8"?><p:sld xmlns:a="http://schemas.openxmlformats.org/drawingml/2006/main" xmlns:r="http://schemas.openxmlformats.org/officeDocument/2006/relationships" xmlns:p="http://schemas.openxmlformats.org/presentationml/2006/main"><p:cSld><p:spTree><p:nvGrpSpPr><p:cNvPr id="1" name="" /><p:cNvGrpSpPr /><p:nvPr /></p:nvGrpSpPr><p:grpSpPr><a:xfrm><a:off x="0" y="0" /><a:ext cx="0" cy="0" /><a:chOff x="0" y="0" /><a:chExt cx="0" cy="0" /></a:xfrm></p:grpSpPr><p:sp><p:nvSpPr><p:cNvPr id="2" name="Title 1" /><p:cNvSpPr><a:spLocks noGrp="1" /></p:cNvSpPr><p:nvPr><p:ph type="title" /></p:nvPr></p:nvSpPr><p:spPr><a:xfrm><a:off x="457201" y="204787" /><a:ext cx="3008313" cy="871538" /></a:xfrm></p:spPr><p:txBody><a:bodyPr /><a:lstStyle /><a:p><a:pPr lvl="0" indent="0" marL="0"><a:buNone /></a:pPr><a:r><a:rPr /><a:t>The controller: four actions, recalibration only inside a bounded band</a:t></a:r></a:p></p:txBody></p:sp><p:sp><p:nvSpPr><p:cNvPr id="4" name="Text Placeholder 3" /><p:cNvSpPr><a:spLocks noGrp="1" /></p:cNvSpPr><p:nvPr><p:ph idx="2" sz="half" type="body" /></p:nvPr></p:nvSpPr><p:spPr /><p:txBody><a:bodyPr /><a:lstStyle /><a:p><a:pPr lvl="0" indent="0" marL="0"><a:buNone /></a:pPr><a:r><a:rPr b="1" /><a:t>[IMPLEMENTED]</a:t></a:r><a:r><a:rPr /><a:t> </a:t></a:r><a:r><a:rPr><a:latin typeface="Courier" /></a:rPr><a:t>AnchoredRecalibrationPolicy</a:t></a:r><a:r><a:rPr /><a:t>. Its buffer holds the last 10 scores of </a:t></a:r><a:r><a:rPr b="1" /><a:t>every</a:t></a:r><a:r><a:rPr /><a:t> window, so what it learns from never depends on its own decisions. Nothing was tuned: 10 and 0.95 are the rolling baseline’s values; the cap 4 and the stability bound 2 are declared operating assumptions.</a:t></a:r></a:p></p:txBody></p:sp><p:graphicFrame><p:nvGraphicFramePr><p:cNvPr id="6" name="Content Placeholder 5" /><p:cNvGraphicFramePr><a:graphicFrameLocks noGrp="1" /></p:cNvGraphicFramePr><p:nvPr><p:ph idx="1" /></p:nvPr></p:nvGraphicFramePr><p:xfrm><a:off x="3568700" y="203200" /><a:ext cx="5105400" cy="4381500" /></p:xfrm><a:graphic><a:graphicData uri="http://schemas.openxmlformats.org/drawingml/2006/table"><a:tbl><a:tblPr firstRow="1" bandRow="1"><a:tableStyleId>{5C22544A-7EE6-4342-B048-85BDC9FD1C3A}</a:tableStyleId></a:tblPr><a:tblGrid><a:gridCol w="2819400" /><a:gridCol w="2286000" /></a:tblGrid><a:tr h="0"><a:tc><a:txBody><a:bodyPr /><a:lstStyle /><a:p><a:pPr lvl="0" indent="0" marL="0" algn="l"><a:buNone /></a:pPr><a:r><a:rPr /><a:t>At a window end</a:t></a:r></a:p></a:txBody><a:tcPr /></a:tc><a:tc><a:txBody><a:bodyPr /><a:lstStyle /><a:p><a:pPr lvl="0" indent="0" marL="0" algn="l"><a:buNone /></a:pPr><a:r><a:rPr /><a:t>Action</a:t></a:r></a:p></a:txBody><a:tcPr /></a:tc></a:tr><a:tr h="0"><a:tc><a:txBody><a:bodyPr /><a:lstStyle /><a:p><a:pPr lvl="0" indent="0" marL="0" algn="l"><a:buNone /></a:pPr><a:r><a:rPr /><a:t>No sustained rise</a:t></a:r></a:p></a:txBody></a:tc><a:tc><a:txBody><a:bodyPr /><a:lstStyle /><a:p><a:pPr lvl="0" indent="0" marL="0" algn="l"><a:buNone /></a:pPr><a:r><a:rPr b="1" /><a:t>hold</a:t></a:r><a:r><a:rPr /><a:t>, or </a:t></a:r><a:r><a:rPr b="1" /><a:t>alert</a:t></a:r><a:r><a:rPr /><a:t> if </a:t></a:r><a14:m><m:oMath xmlns:m="http://schemas.openxmlformats.org/officeDocument/2006/math"><m:r><m:t>s</m:t></m:r><m:r><m:rPr><m:sty m:val="p" /></m:rPr><m:t>&gt;</m:t></m:r><m:r><m:t>θ</m:t></m:r></m:oMath></a14:m></a:p></a:txBody></a:tc></a:tr><a:tr h="0"><a:tc><a:txBody><a:bodyPr /><a:lstStyle /><a:p><a:pPr lvl="0" indent="0" marL="0" algn="l"><a:buNone /></a:pPr><a:r><a:rPr /><a:t>Sustained rise that is stable and at most </a:t></a:r><a14:m><m:oMath xmlns:m="http://schemas.openxmlformats.org/officeDocument/2006/math"><m:r><m:t>4</m:t></m:r><m:sSub><m:e><m:r><m:t>θ</m:t></m:r></m:e><m:sub><m:r><m:t>0</m:t></m:r></m:sub></m:sSub></m:oMath></a14:m></a:p></a:txBody></a:tc><a:tc><a:txBody><a:bodyPr /><a:lstStyle /><a:p><a:pPr lvl="0" indent="0" marL="0" algn="l"><a:buNone /></a:pPr><a:r><a:rPr b="1" /><a:t>recalibrate</a:t></a:r><a:r><a:rPr /><a:t> up to it</a:t></a:r></a:p></a:txBody></a:tc></a:tr><a:tr h="0"><a:tc><a:txBody><a:bodyPr /><a:lstStyle /><a:p><a:pPr lvl="0" indent="0" marL="0" algn="l"><a:buNone /></a:pPr><a:r><a:rPr /><a:t>Sustained rise, guard fails</a:t></a:r></a:p></a:txBody></a:tc><a:tc><a:txBody><a:bodyPr /><a:lstStyle /><a:p><a:pPr lvl="0" indent="0" marL="0" algn="l"><a:buNone /></a:pPr><a:r><a:rPr b="1" /><a:t>defer</a:t></a:r><a:r><a:rPr /><a:t>, at most 10 in a row</a:t></a:r></a:p></a:txBody></a:tc></a:tr><a:tr h="0"><a:tc><a:txBody><a:bodyPr /><a:lstStyle /><a:p><a:pPr lvl="0" indent="0" marL="0" algn="l"><a:buNone /></a:pPr><a:r><a:rPr /><a:t>Still failing after 10 deferrals</a:t></a:r></a:p></a:txBody></a:tc><a:tc><a:txBody><a:bodyPr /><a:lstStyle /><a:p><a:pPr lvl="0" indent="0" marL="0" algn="l"><a:buNone /></a:pPr><a:r><a:rPr b="1" /><a:t>escalate</a:t></a:r><a:r><a:rPr /><a:t>: alert-capable, no recalibration</a:t></a:r></a:p></a:txBody></a:tc></a:tr><a:tr h="0"><a:tc><a:txBody><a:bodyPr /><a:lstStyle /><a:p><a:pPr lvl="0" indent="0" marL="0" algn="l"><a:buNone /></a:pPr><a:r><a:rPr /><a:t>Rise over</a:t></a:r></a:p></a:txBody></a:tc><a:tc><a:txBody><a:bodyPr /><a:lstStyle /><a:p><a:pPr lvl="0" indent="0" marL="0" algn="l"><a:buNone /></a:pPr><a:r><a:rPr b="1" /><a:t>recalibrate</a:t></a:r><a:r><a:rPr /><a:t> back toward </a:t></a:r><a14:m><m:oMath xmlns:m="http://schemas.openxmlformats.org/officeDocument/2006/math"><m:sSub><m:e><m:r><m:t>θ</m:t></m:r></m:e><m:sub><m:r><m:t>0</m:t></m:r></m:sub></m:sSub></m:oMath></a14:m></a:p></a:txBody></a:tc></a:tr></a:tbl></a:graphicData></a:graphic></p:graphicFrame></p:spTree></p:cSld></p:sld>
 </file>
 
 <file path=ppt/theme/theme1.xml><?xml version="1.0" encoding="utf-8"?>

</xml_diff>

<commit_message>
docs(phase1): reconcile report and viva deck claims
Align the report and speaker notes with the frozen synthetic protocol and saved results. Clarify the cap trade-off, persistence outcomes, parameter origins, and the limits of the Phase-I evidence. Remove an unsupported description of the SKAB setup.

Rebuild the 15-page report and 15-slide PDF and PowerPoint deck from the canonical sources. Verification: 504 tests run with 12 skipped; 99 evaluation rows recomputed with zero mismatches; the documented deliverable build and checksum checks passed.
</commit_message>
<xml_diff>
--- a/deliverables/Phase-I-Slides.pptx
+++ b/deliverables/Phase-I-Slides.pptx
@@ -538,7 +538,17 @@
             </a:pPr>
             <a:r>
               <a:rPr/>
-              <a:t>First, the setting, in half a minute. A machine carries sensors. We use one: the current drawn by the electric motor of a water-circulation rig, from SKAB, a public laboratory benchmark. The signal is cut into short windows. A fixed scorer, which is not our contribution, gives each window an anomaly score: higher means more unusual. A policy turns each score into a decision; the simplest one alerts when the score is above a threshold. An operator then checks every alert. So the system can fail in two ways: it can miss a real fault, or it can raise false alerts, and each false alert spends someone’s time. Our research is about the policy, box three.</a:t>
+              <a:t>First, the setting, in half a minute. A machine carries sensors. We use the </a:t>
+            </a:r>
+            <a:r>
+              <a:rPr>
+                <a:latin typeface="Courier"/>
+              </a:rPr>
+              <a:t>Current</a:t>
+            </a:r>
+            <a:r>
+              <a:rPr/>
+              <a:t> channel in two SKAB development streams. The signal is cut into short windows. A fixed scorer, which is not our contribution, gives each window an anomaly score: higher means more unusual. A policy turns each score into a decision; the simplest one alerts when the score is above a threshold. An operator then checks every alert. So the system can fail in two ways: it can miss a real fault, or it can raise false alerts, and each false alert spends someone’s time. Our research is about the policy, box three.</a:t>
             </a:r>
           </a:p>
         </p:txBody>
@@ -620,7 +630,7 @@
             </a:pPr>
             <a:r>
               <a:rPr/>
-              <a:t>The controller in one table. With no sustained rise it behaves like a fixed threshold. When the recent median rises and the rise is stable and inside four times the calibration threshold, it recalibrates. If the rise is unstable it defers, up to ten times, then escalates and keeps alerting without learning. When the rise ends it returns toward the anchor. The parameters come from the existing baseline or are declared assumptions; none was chosen by looking at results.</a:t>
+              <a:t>The controller in one table. With no sustained rise it behaves like a fixed threshold. When the recent median rises and the rise is stable and inside four times the calibration threshold, it recalibrates. If the rise is unstable it defers, up to ten times, then escalates and keeps alerting without learning. When the rise ends it returns toward the anchor. The buffer length and quantile came from the existing baseline; the defer limit equals the buffer length. The cap and stability bound are declared assumptions. All were fixed before the policy study outcomes.</a:t>
             </a:r>
           </a:p>
         </p:txBody>
@@ -702,7 +712,7 @@
             </a:pPr>
             <a:r>
               <a:rPr/>
-              <a:t>These engineered cases show the mechanism and its failures. On a clean benign step it adapts and cuts false-alert time from 597 to 16 while deciding on every window. After adapting it still catches later faults. On a slow ramp it locks into repeated alerts, a real failure we report. And a fault shaped exactly like a benign step is absorbed; we declared that limit in advance, because no label-free rule can tell the two apart.</a:t>
+              <a:t>These engineered cases show the mechanism and its failures. On a clean benign step it adapts and cuts false-alert time from 597 to 16 while deciding on every window. After adapting it still catches later faults. Y5 is a spiky fault without a preceding step; it tests the cost of deferring at onset. Y6 is a benign step beyond the cap: keeping the cap produces 757 non-event samples, while removing it produces 16, but also lowers Y3 fault visibility from 0.29 to 0.16. On the Y2 ramp it recalibrates once, defers three times, then produces 204 non-event samples over 50 episodes, versus 577 with no deferral. A fault shaped exactly like a benign step is absorbed; we declared that limit in advance, because no label-free rule can tell the two apart.</a:t>
             </a:r>
           </a:p>
         </p:txBody>
@@ -866,7 +876,7 @@
             </a:pPr>
             <a:r>
               <a:rPr/>
-              <a:t>This is the slide we most want to be honest on. On the benign cases the simplest rule, learning from every window, is quieter than ours: 12 against 16, and 28 against 204. Our only argument is that we keep faults visible: 0.29 of the Y3 fault against 0.04. On SKAB we are identical to fixed, so it proves nothing either way. We therefore claim a mechanism and a finding, not a winner.</a:t>
+              <a:t>This is the slide we most want to be honest on. On the benign cases the simplest rule, learning from every window, is quieter than ours: 12 against 16, and 28 against 204. Our fault-retention evidence is 0.29 of the Y3 fault against 0.04. H3’s predeclared criteria are met on engineered cases, including reduced workload against fixed on the ramp, but admit-all is quieter there. On SKAB we are identical to fixed, so it gives no evidence of real-world benefit. We therefore claim a mechanism and a bounded finding, not a winner.</a:t>
             </a:r>
           </a:p>
         </p:txBody>
@@ -948,7 +958,7 @@
             </a:pPr>
             <a:r>
               <a:rPr/>
-              <a:t>To close, what we have not shown and how we will find out. We have no real-world benefit and no held-out result, the data has one event per stream on one channel, and we make no claim about the reserved stream. The next experiment is committed in advance, so we cannot move the goalposts: every policy is replayed on the other SKAB valve files, chosen without looking at labels, plus a dataset with genuine benign shifts. Any one of three outcomes kills the direction, and then that becomes our result. Thank you; we are happy to take questions.</a:t>
+              <a:t>To close, what we have not shown and how we will find out. We have no real-world benefit and no held-out result, the data has one event per stream on one channel, and we make no claim about the reserved stream. The next experiment is committed in advance: every policy is replayed on the other SKAB valve files, admitted by file name without looking at outcomes; the calibration boundary uses source labels as declared in the protocol. We also need one public family with labelled benign shifts and a licence suitable for the study. Any one of three outcomes kills the direction and becomes our result. Thank you; we are happy to take questions.</a:t>
             </a:r>
           </a:p>
         </p:txBody>
@@ -1522,7 +1532,7 @@
             </a:pPr>
             <a:r>
               <a:rPr/>
-              <a:t>The SKAB table, read narrowly. Every policy that alerts finds the one event per stream. What separates them is workload. The normal-only rolling policy needs 16 times the alert windows on valve1 and nearly 4 times on valve2 for the same event: the ratchet’s cost. Our controller is identical to fixed, because its guard never fires on this data. That is a no-harm check, not a win. Sun et al. look quiet only because they decide on about 40 percent of windows.</a:t>
+              <a:t>The SKAB table, read narrowly. The alerting policies shown find the one event per stream. What separates them is workload. The normal-only rolling policy needs 16 times the alert windows on valve1 and nearly 4 times on valve2 for the same event: the ratchet’s cost. Our controller is identical to fixed, because its guard never fires on this data. That is a no-harm check, not a win. Sun et al. look quiet only because they decide on about 40 percent of windows.</a:t>
             </a:r>
           </a:p>
         </p:txBody>
@@ -1604,7 +1614,7 @@
             </a:pPr>
             <a:r>
               <a:rPr/>
-              <a:t>Why do the persistence rules miss the events? Because of the scorer. Inside the event only 6 of 100 windows on valve1 and 13 of 98 on valve2 even cross the threshold, and never more than two in a row. A rule that waits for three in a row has nothing to fire on. And since each event covers most of the replay, one alert anywhere scores full recall, so on SKAB we read workload and false episodes, not recall.</a:t>
+              <a:t>Why does the 3-consecutive rule miss both events? Because of the scorer. Inside the event only 6 of 100 windows on valve1 and 13 of 98 on valve2 even cross the threshold, and never more than two in a row. The 3-of-5 rule can use non-consecutive crossings: it misses valve1 but catches valve2. Since each event covers most of the replay, one alert anywhere scores full recall, so on SKAB we read workload and false episodes, not recall.</a:t>
             </a:r>
           </a:p>
         </p:txBody>
@@ -4817,7 +4827,7 @@
                 </a:r>
                 <a:r>
                   <a:rPr/>
-                  <a:t> in a row, so rules needing 3 miss the events. Each event spans about </a:t>
+                  <a:t> in a row. A 3-consecutive rule misses both; a 3-of-5 rule misses valve1 but catches valve2. Each event spans about </a:t>
                 </a:r>
                 <a:r>
                   <a:rPr b="1"/>
@@ -4871,7 +4881,7 @@
 </p:sld>
 </file>
 
-<file path=ppt/slides/slide11.xml><?xml version="1.0" encoding="UTF-8"?><p:sld xmlns:a="http://schemas.openxmlformats.org/drawingml/2006/main" xmlns:r="http://schemas.openxmlformats.org/officeDocument/2006/relationships" xmlns:p="http://schemas.openxmlformats.org/presentationml/2006/main"><p:cSld><p:spTree><p:nvGrpSpPr><p:cNvPr id="1" name="" /><p:cNvGrpSpPr /><p:nvPr /></p:nvGrpSpPr><p:grpSpPr><a:xfrm><a:off x="0" y="0" /><a:ext cx="0" cy="0" /><a:chOff x="0" y="0" /><a:chExt cx="0" cy="0" /></a:xfrm></p:grpSpPr><p:sp><p:nvSpPr><p:cNvPr id="2" name="Title 1" /><p:cNvSpPr><a:spLocks noGrp="1" /></p:cNvSpPr><p:nvPr><p:ph type="title" /></p:nvPr></p:nvSpPr><p:spPr><a:xfrm><a:off x="457201" y="204787" /><a:ext cx="3008313" cy="871538" /></a:xfrm></p:spPr><p:txBody><a:bodyPr /><a:lstStyle /><a:p><a:pPr lvl="0" indent="0" marL="0"><a:buNone /></a:pPr><a:r><a:rPr /><a:t>The controller: four actions, recalibration only inside a bounded band</a:t></a:r></a:p></p:txBody></p:sp><p:sp><p:nvSpPr><p:cNvPr id="4" name="Text Placeholder 3" /><p:cNvSpPr><a:spLocks noGrp="1" /></p:cNvSpPr><p:nvPr><p:ph idx="2" sz="half" type="body" /></p:nvPr></p:nvSpPr><p:spPr /><p:txBody><a:bodyPr /><a:lstStyle /><a:p><a:pPr lvl="0" indent="0" marL="0"><a:buNone /></a:pPr><a:r><a:rPr b="1" /><a:t>[IMPLEMENTED]</a:t></a:r><a:r><a:rPr /><a:t> </a:t></a:r><a:r><a:rPr><a:latin typeface="Courier" /></a:rPr><a:t>AnchoredRecalibrationPolicy</a:t></a:r><a:r><a:rPr /><a:t>. Its buffer holds the last 10 scores of </a:t></a:r><a:r><a:rPr b="1" /><a:t>every</a:t></a:r><a:r><a:rPr /><a:t> window, so what it learns from never depends on its own decisions. Nothing was tuned: 10 and 0.95 are the rolling baseline’s values; the cap 4 and the stability bound 2 are declared operating assumptions.</a:t></a:r></a:p></p:txBody></p:sp><p:graphicFrame><p:nvGraphicFramePr><p:cNvPr id="6" name="Content Placeholder 5" /><p:cNvGraphicFramePr><a:graphicFrameLocks noGrp="1" /></p:cNvGraphicFramePr><p:nvPr><p:ph idx="1" /></p:nvPr></p:nvGraphicFramePr><p:xfrm><a:off x="3568700" y="203200" /><a:ext cx="5105400" cy="4381500" /></p:xfrm><a:graphic><a:graphicData uri="http://schemas.openxmlformats.org/drawingml/2006/table"><a:tbl><a:tblPr firstRow="1" bandRow="1"><a:tableStyleId>{5C22544A-7EE6-4342-B048-85BDC9FD1C3A}</a:tableStyleId></a:tblPr><a:tblGrid><a:gridCol w="2819400" /><a:gridCol w="2286000" /></a:tblGrid><a:tr h="0"><a:tc><a:txBody><a:bodyPr /><a:lstStyle /><a:p><a:pPr lvl="0" indent="0" marL="0" algn="l"><a:buNone /></a:pPr><a:r><a:rPr /><a:t>At a window end</a:t></a:r></a:p></a:txBody><a:tcPr /></a:tc><a:tc><a:txBody><a:bodyPr /><a:lstStyle /><a:p><a:pPr lvl="0" indent="0" marL="0" algn="l"><a:buNone /></a:pPr><a:r><a:rPr /><a:t>Action</a:t></a:r></a:p></a:txBody><a:tcPr /></a:tc></a:tr><a:tr h="0"><a:tc><a:txBody><a:bodyPr /><a:lstStyle /><a:p><a:pPr lvl="0" indent="0" marL="0" algn="l"><a:buNone /></a:pPr><a:r><a:rPr /><a:t>No sustained rise</a:t></a:r></a:p></a:txBody></a:tc><a:tc><a:txBody><a:bodyPr /><a:lstStyle /><a:p><a:pPr lvl="0" indent="0" marL="0" algn="l"><a:buNone /></a:pPr><a:r><a:rPr b="1" /><a:t>hold</a:t></a:r><a:r><a:rPr /><a:t>, or </a:t></a:r><a:r><a:rPr b="1" /><a:t>alert</a:t></a:r><a:r><a:rPr /><a:t> if </a:t></a:r><a14:m><m:oMath xmlns:m="http://schemas.openxmlformats.org/officeDocument/2006/math"><m:r><m:t>s</m:t></m:r><m:r><m:rPr><m:sty m:val="p" /></m:rPr><m:t>&gt;</m:t></m:r><m:r><m:t>θ</m:t></m:r></m:oMath></a14:m></a:p></a:txBody></a:tc></a:tr><a:tr h="0"><a:tc><a:txBody><a:bodyPr /><a:lstStyle /><a:p><a:pPr lvl="0" indent="0" marL="0" algn="l"><a:buNone /></a:pPr><a:r><a:rPr /><a:t>Sustained rise that is stable and at most </a:t></a:r><a14:m><m:oMath xmlns:m="http://schemas.openxmlformats.org/officeDocument/2006/math"><m:r><m:t>4</m:t></m:r><m:sSub><m:e><m:r><m:t>θ</m:t></m:r></m:e><m:sub><m:r><m:t>0</m:t></m:r></m:sub></m:sSub></m:oMath></a14:m></a:p></a:txBody></a:tc><a:tc><a:txBody><a:bodyPr /><a:lstStyle /><a:p><a:pPr lvl="0" indent="0" marL="0" algn="l"><a:buNone /></a:pPr><a:r><a:rPr b="1" /><a:t>recalibrate</a:t></a:r><a:r><a:rPr /><a:t> up to it</a:t></a:r></a:p></a:txBody></a:tc></a:tr><a:tr h="0"><a:tc><a:txBody><a:bodyPr /><a:lstStyle /><a:p><a:pPr lvl="0" indent="0" marL="0" algn="l"><a:buNone /></a:pPr><a:r><a:rPr /><a:t>Sustained rise, guard fails</a:t></a:r></a:p></a:txBody></a:tc><a:tc><a:txBody><a:bodyPr /><a:lstStyle /><a:p><a:pPr lvl="0" indent="0" marL="0" algn="l"><a:buNone /></a:pPr><a:r><a:rPr b="1" /><a:t>defer</a:t></a:r><a:r><a:rPr /><a:t>, at most 10 in a row</a:t></a:r></a:p></a:txBody></a:tc></a:tr><a:tr h="0"><a:tc><a:txBody><a:bodyPr /><a:lstStyle /><a:p><a:pPr lvl="0" indent="0" marL="0" algn="l"><a:buNone /></a:pPr><a:r><a:rPr /><a:t>Still failing after 10 deferrals</a:t></a:r></a:p></a:txBody></a:tc><a:tc><a:txBody><a:bodyPr /><a:lstStyle /><a:p><a:pPr lvl="0" indent="0" marL="0" algn="l"><a:buNone /></a:pPr><a:r><a:rPr b="1" /><a:t>escalate</a:t></a:r><a:r><a:rPr /><a:t>: alert-capable, no recalibration</a:t></a:r></a:p></a:txBody></a:tc></a:tr><a:tr h="0"><a:tc><a:txBody><a:bodyPr /><a:lstStyle /><a:p><a:pPr lvl="0" indent="0" marL="0" algn="l"><a:buNone /></a:pPr><a:r><a:rPr /><a:t>Rise over</a:t></a:r></a:p></a:txBody></a:tc><a:tc><a:txBody><a:bodyPr /><a:lstStyle /><a:p><a:pPr lvl="0" indent="0" marL="0" algn="l"><a:buNone /></a:pPr><a:r><a:rPr b="1" /><a:t>recalibrate</a:t></a:r><a:r><a:rPr /><a:t> back toward </a:t></a:r><a14:m><m:oMath xmlns:m="http://schemas.openxmlformats.org/officeDocument/2006/math"><m:sSub><m:e><m:r><m:t>θ</m:t></m:r></m:e><m:sub><m:r><m:t>0</m:t></m:r></m:sub></m:sSub></m:oMath></a14:m></a:p></a:txBody></a:tc></a:tr></a:tbl></a:graphicData></a:graphic></p:graphicFrame></p:spTree></p:cSld></p:sld>
+<file path=ppt/slides/slide11.xml><?xml version="1.0" encoding="UTF-8"?><p:sld xmlns:a="http://schemas.openxmlformats.org/drawingml/2006/main" xmlns:r="http://schemas.openxmlformats.org/officeDocument/2006/relationships" xmlns:p="http://schemas.openxmlformats.org/presentationml/2006/main"><p:cSld><p:spTree><p:nvGrpSpPr><p:cNvPr id="1" name="" /><p:cNvGrpSpPr /><p:nvPr /></p:nvGrpSpPr><p:grpSpPr><a:xfrm><a:off x="0" y="0" /><a:ext cx="0" cy="0" /><a:chOff x="0" y="0" /><a:chExt cx="0" cy="0" /></a:xfrm></p:grpSpPr><p:sp><p:nvSpPr><p:cNvPr id="2" name="Title 1" /><p:cNvSpPr><a:spLocks noGrp="1" /></p:cNvSpPr><p:nvPr><p:ph type="title" /></p:nvPr></p:nvSpPr><p:spPr><a:xfrm><a:off x="457201" y="204787" /><a:ext cx="3008313" cy="871538" /></a:xfrm></p:spPr><p:txBody><a:bodyPr /><a:lstStyle /><a:p><a:pPr lvl="0" indent="0" marL="0"><a:buNone /></a:pPr><a:r><a:rPr /><a:t>Four actions keep recalibration inside a bounded band</a:t></a:r></a:p></p:txBody></p:sp><p:sp><p:nvSpPr><p:cNvPr id="4" name="Text Placeholder 3" /><p:cNvSpPr><a:spLocks noGrp="1" /></p:cNvSpPr><p:nvPr><p:ph idx="2" sz="half" type="body" /></p:nvPr></p:nvSpPr><p:spPr /><p:txBody><a:bodyPr /><a:lstStyle /><a:p><a:pPr lvl="0" indent="0" marL="0"><a:buNone /></a:pPr><a:r><a:rPr b="1" /><a:t>[IMPLEMENTED]</a:t></a:r><a:r><a:rPr /><a:t> </a:t></a:r><a:r><a:rPr><a:latin typeface="Courier" /></a:rPr><a:t>AnchoredRecalibrationPolicy</a:t></a:r><a:r><a:rPr /><a:t>. Its buffer holds the last 10 scores of </a:t></a:r><a:r><a:rPr b="1" /><a:t>every</a:t></a:r><a:r><a:rPr /><a:t> window, so what it learns from never depends on its own decisions. All parameters were fixed before the policy study: 10 and 0.95 came from the rolling baseline, the defer limit equals 10, and cap 4 and stability bound 2 are declared operating assumptions.</a:t></a:r></a:p></p:txBody></p:sp><p:graphicFrame><p:nvGraphicFramePr><p:cNvPr id="6" name="Content Placeholder 5" /><p:cNvGraphicFramePr><a:graphicFrameLocks noGrp="1" /></p:cNvGraphicFramePr><p:nvPr><p:ph idx="1" /></p:nvPr></p:nvGraphicFramePr><p:xfrm><a:off x="3568700" y="203200" /><a:ext cx="5105400" cy="4381500" /></p:xfrm><a:graphic><a:graphicData uri="http://schemas.openxmlformats.org/drawingml/2006/table"><a:tbl><a:tblPr firstRow="1" bandRow="1"><a:tableStyleId>{5C22544A-7EE6-4342-B048-85BDC9FD1C3A}</a:tableStyleId></a:tblPr><a:tblGrid><a:gridCol w="2819400" /><a:gridCol w="2286000" /></a:tblGrid><a:tr h="0"><a:tc><a:txBody><a:bodyPr /><a:lstStyle /><a:p><a:pPr lvl="0" indent="0" marL="0" algn="l"><a:buNone /></a:pPr><a:r><a:rPr /><a:t>At a window end</a:t></a:r></a:p></a:txBody><a:tcPr /></a:tc><a:tc><a:txBody><a:bodyPr /><a:lstStyle /><a:p><a:pPr lvl="0" indent="0" marL="0" algn="l"><a:buNone /></a:pPr><a:r><a:rPr /><a:t>Action</a:t></a:r></a:p></a:txBody><a:tcPr /></a:tc></a:tr><a:tr h="0"><a:tc><a:txBody><a:bodyPr /><a:lstStyle /><a:p><a:pPr lvl="0" indent="0" marL="0" algn="l"><a:buNone /></a:pPr><a:r><a:rPr /><a:t>No sustained rise</a:t></a:r></a:p></a:txBody></a:tc><a:tc><a:txBody><a:bodyPr /><a:lstStyle /><a:p><a:pPr lvl="0" indent="0" marL="0" algn="l"><a:buNone /></a:pPr><a:r><a:rPr b="1" /><a:t>hold</a:t></a:r><a:r><a:rPr /><a:t>, or </a:t></a:r><a:r><a:rPr b="1" /><a:t>alert</a:t></a:r><a:r><a:rPr /><a:t> if </a:t></a:r><a14:m><m:oMath xmlns:m="http://schemas.openxmlformats.org/officeDocument/2006/math"><m:r><m:t>s</m:t></m:r><m:r><m:rPr><m:sty m:val="p" /></m:rPr><m:t>&gt;</m:t></m:r><m:r><m:t>θ</m:t></m:r></m:oMath></a14:m></a:p></a:txBody></a:tc></a:tr><a:tr h="0"><a:tc><a:txBody><a:bodyPr /><a:lstStyle /><a:p><a:pPr lvl="0" indent="0" marL="0" algn="l"><a:buNone /></a:pPr><a:r><a:rPr /><a:t>Sustained rise that is stable and at most </a:t></a:r><a14:m><m:oMath xmlns:m="http://schemas.openxmlformats.org/officeDocument/2006/math"><m:r><m:t>4</m:t></m:r><m:sSub><m:e><m:r><m:t>θ</m:t></m:r></m:e><m:sub><m:r><m:t>0</m:t></m:r></m:sub></m:sSub></m:oMath></a14:m></a:p></a:txBody></a:tc><a:tc><a:txBody><a:bodyPr /><a:lstStyle /><a:p><a:pPr lvl="0" indent="0" marL="0" algn="l"><a:buNone /></a:pPr><a:r><a:rPr b="1" /><a:t>recalibrate</a:t></a:r><a:r><a:rPr /><a:t> up to it</a:t></a:r></a:p></a:txBody></a:tc></a:tr><a:tr h="0"><a:tc><a:txBody><a:bodyPr /><a:lstStyle /><a:p><a:pPr lvl="0" indent="0" marL="0" algn="l"><a:buNone /></a:pPr><a:r><a:rPr /><a:t>Sustained rise, guard fails</a:t></a:r></a:p></a:txBody></a:tc><a:tc><a:txBody><a:bodyPr /><a:lstStyle /><a:p><a:pPr lvl="0" indent="0" marL="0" algn="l"><a:buNone /></a:pPr><a:r><a:rPr b="1" /><a:t>defer</a:t></a:r><a:r><a:rPr /><a:t>, at most 10 in a row</a:t></a:r></a:p></a:txBody></a:tc></a:tr><a:tr h="0"><a:tc><a:txBody><a:bodyPr /><a:lstStyle /><a:p><a:pPr lvl="0" indent="0" marL="0" algn="l"><a:buNone /></a:pPr><a:r><a:rPr /><a:t>Still failing after 10 deferrals</a:t></a:r></a:p></a:txBody></a:tc><a:tc><a:txBody><a:bodyPr /><a:lstStyle /><a:p><a:pPr lvl="0" indent="0" marL="0" algn="l"><a:buNone /></a:pPr><a:r><a:rPr b="1" /><a:t>escalate</a:t></a:r><a:r><a:rPr /><a:t>: alert-capable, no recalibration</a:t></a:r></a:p></a:txBody></a:tc></a:tr><a:tr h="0"><a:tc><a:txBody><a:bodyPr /><a:lstStyle /><a:p><a:pPr lvl="0" indent="0" marL="0" algn="l"><a:buNone /></a:pPr><a:r><a:rPr /><a:t>Rise over</a:t></a:r></a:p></a:txBody></a:tc><a:tc><a:txBody><a:bodyPr /><a:lstStyle /><a:p><a:pPr lvl="0" indent="0" marL="0" algn="l"><a:buNone /></a:pPr><a:r><a:rPr b="1" /><a:t>recalibrate</a:t></a:r><a:r><a:rPr /><a:t> back toward </a:t></a:r><a14:m><m:oMath xmlns:m="http://schemas.openxmlformats.org/officeDocument/2006/math"><m:sSub><m:e><m:r><m:t>θ</m:t></m:r></m:e><m:sub><m:r><m:t>0</m:t></m:r></m:sub></m:sSub></m:oMath></a14:m></a:p></a:txBody></a:tc></a:tr></a:tbl></a:graphicData></a:graphic></p:graphicFrame></p:spTree></p:cSld></p:sld>
 </file>
 
 <file path=ppt/slides/slide12.xml><?xml version="1.0" encoding="utf-8"?>
@@ -4911,7 +4921,7 @@
             </a:pPr>
             <a:r>
               <a:rPr/>
-              <a:t>Under stress: adapts to a step, fails on a ramp and a step-shaped fault</a:t>
+              <a:t>Under stress: step adaptation, costly ramp, and an indistinguishable fault</a:t>
             </a:r>
           </a:p>
         </p:txBody>
@@ -5007,11 +5017,11 @@
             <a:pPr lvl="0"/>
             <a:r>
               <a:rPr b="1"/>
-              <a:t>Fails, Y2 ramp:</a:t>
+              <a:t>Costly, Y2 ramp:</a:t>
             </a:r>
             <a:r>
               <a:rPr/>
-              <a:t> locks into alerts, </a:t>
+              <a:t> </a:t>
             </a:r>
             <a:r>
               <a:rPr b="1"/>
@@ -5019,7 +5029,7 @@
             </a:r>
             <a:r>
               <a:rPr/>
-              <a:t> over 50 episodes</a:t>
+              <a:t> non-event samples over 50 episodes, 3 deferrals</a:t>
             </a:r>
           </a:p>
           <a:p>
@@ -5254,7 +5264,7 @@
             </a:pPr>
             <a:r>
               <a:rPr b="1"/>
-              <a:t>These results do not establish a useful controller.</a:t>
+              <a:t>Real-world benefit and policy superiority remain unproven.</a:t>
             </a:r>
           </a:p>
           <a:p>
@@ -5291,7 +5301,7 @@
             <a:pPr lvl="0"/>
             <a:r>
               <a:rPr b="1"/>
-              <a:t>SKAB gives no evidence either way:</a:t>
+              <a:t>SKAB gives no evidence of benefit:</a:t>
             </a:r>
             <a:r>
               <a:rPr/>
@@ -5609,7 +5619,17 @@
             </a:r>
             <a:r>
               <a:rPr/>
-              <a:t> SKAB, a public benchmark recorded on a laboratory water-circulation rig. We use one sensor, the current drawn by its electric motor. </a:t>
+              <a:t> two SKAB development streams, scored on the </a:t>
+            </a:r>
+            <a:r>
+              <a:rPr>
+                <a:latin typeface="Courier"/>
+              </a:rPr>
+              <a:t>Current</a:t>
+            </a:r>
+            <a:r>
+              <a:rPr/>
+              <a:t> channel. </a:t>
             </a:r>
             <a:r>
               <a:rPr b="1"/>
@@ -6452,7 +6472,7 @@
 </p:sld>
 </file>
 
-<file path=ppt/slides/slide5.xml><?xml version="1.0" encoding="UTF-8"?><p:sld xmlns:a="http://schemas.openxmlformats.org/drawingml/2006/main" xmlns:r="http://schemas.openxmlformats.org/officeDocument/2006/relationships" xmlns:p="http://schemas.openxmlformats.org/presentationml/2006/main"><p:cSld><p:spTree><p:nvGrpSpPr><p:cNvPr id="1" name="" /><p:cNvGrpSpPr /><p:nvPr /></p:nvGrpSpPr><p:grpSpPr><a:xfrm><a:off x="0" y="0" /><a:ext cx="0" cy="0" /><a:chOff x="0" y="0" /><a:chExt cx="0" cy="0" /></a:xfrm></p:grpSpPr><p:sp><p:nvSpPr><p:cNvPr id="2" name="Title 1" /><p:cNvSpPr><a:spLocks noGrp="1" /></p:cNvSpPr><p:nvPr><p:ph type="title" /></p:nvPr></p:nvSpPr><p:spPr><a:xfrm><a:off x="457201" y="204787" /><a:ext cx="3008313" cy="871538" /></a:xfrm></p:spPr><p:txBody><a:bodyPr /><a:lstStyle /><a:p><a:pPr lvl="0" indent="0" marL="0"><a:buNone /></a:pPr><a:r><a:rPr /><a:t>Our direction: recalibration as a guarded, auditable action</a:t></a:r></a:p></p:txBody></p:sp><p:sp><p:nvSpPr><p:cNvPr id="4" name="Text Placeholder 3" /><p:cNvSpPr><a:spLocks noGrp="1" /></p:cNvSpPr><p:nvPr><p:ph idx="2" sz="half" type="body" /></p:nvPr></p:nvSpPr><p:spPr /><p:txBody><a:bodyPr /><a:lstStyle /><a:p><a:pPr lvl="0" indent="0" marL="0"><a:buNone /></a:pPr><a:r><a:rPr /><a:t>Recalibrate only as a deliberate decision, from data chosen </a:t></a:r><a:r><a:rPr b="1" /><a:t>neither by the threshold itself nor unconditionally</a:t></a:r><a:r><a:rPr /><a:t>, and judge every policy on </a:t></a:r><a:r><a:rPr b="1" /><a:t>identical scores</a:t></a:r><a:r><a:rPr /><a:t>. Tags: PROVED = theorem · MEASURED = saved, recomputed result · IMPLEMENTED = tested code · PROPOSED = not yet tested.</a:t></a:r></a:p></p:txBody></p:sp><p:graphicFrame><p:nvGraphicFramePr><p:cNvPr id="6" name="Content Placeholder 5" /><p:cNvGraphicFramePr><a:graphicFrameLocks noGrp="1" /></p:cNvGraphicFramePr><p:nvPr><p:ph idx="1" /></p:nvPr></p:nvGraphicFramePr><p:xfrm><a:off x="3568700" y="203200" /><a:ext cx="5105400" cy="4381500" /></p:xfrm><a:graphic><a:graphicData uri="http://schemas.openxmlformats.org/drawingml/2006/table"><a:tbl><a:tblPr firstRow="1" bandRow="1"><a:tableStyleId>{5C22544A-7EE6-4342-B048-85BDC9FD1C3A}</a:tableStyleId></a:tblPr><a:tblGrid><a:gridCol w="965200" /><a:gridCol w="4140200" /></a:tblGrid><a:tr h="0"><a:tc><a:txBody><a:bodyPr /><a:lstStyle /><a:p><a:pPr lvl="0" indent="0" marL="0" algn="l"><a:buNone /></a:pPr><a:r><a:rPr /><a:t>Evidence</a:t></a:r></a:p></a:txBody><a:tcPr /></a:tc><a:tc><a:txBody><a:bodyPr /><a:lstStyle /><a:p><a:pPr lvl="0" indent="0" marL="0" algn="l"><a:buNone /></a:pPr><a:r><a:rPr /><a:t>What we claim</a:t></a:r></a:p></a:txBody><a:tcPr /></a:tc></a:tr><a:tr h="0"><a:tc><a:txBody><a:bodyPr /><a:lstStyle /><a:p><a:pPr lvl="0" indent="0" marL="0" algn="l"><a:buNone /></a:pPr><a:r><a:rPr b="1" /><a:t>[PROVED]</a:t></a:r></a:p></a:txBody></a:tc><a:tc><a:txBody><a:bodyPr /><a:lstStyle /><a:p><a:pPr lvl="0" indent="0" marL="0" algn="l"><a:buNone /></a:pPr><a:r><a:rPr /><a:t>C1: learning only from “normal” windows means the threshold never rises</a:t></a:r></a:p></a:txBody></a:tc></a:tr><a:tr h="0"><a:tc><a:txBody><a:bodyPr /><a:lstStyle /><a:p><a:pPr lvl="0" indent="0" marL="0" algn="l"><a:buNone /></a:pPr><a:r><a:rPr b="1" /><a:t>[MEASURED]</a:t></a:r></a:p></a:txBody></a:tc><a:tc><a:txBody><a:bodyPr /><a:lstStyle /><a:p><a:pPr lvl="0" indent="0" marL="0" algn="l"><a:buNone /></a:pPr><a:r><a:rPr /><a:t>C2: on SKAB that costs 16.2× and 3.9× the alert windows</a:t></a:r></a:p></a:txBody></a:tc></a:tr><a:tr h="0"><a:tc><a:txBody><a:bodyPr /><a:lstStyle /><a:p><a:pPr lvl="0" indent="0" marL="0" algn="l"><a:buNone /></a:pPr><a:r><a:rPr b="1" /><a:t>[MEASURED]</a:t></a:r></a:p></a:txBody></a:tc><a:tc><a:txBody><a:bodyPr /><a:lstStyle /><a:p><a:pPr lvl="0" indent="0" marL="0" algn="l"><a:buNone /></a:pPr><a:r><a:rPr /><a:t>C3: the scorer, not the policy, limits detection</a:t></a:r></a:p></a:txBody></a:tc></a:tr><a:tr h="0"><a:tc><a:txBody><a:bodyPr /><a:lstStyle /><a:p><a:pPr lvl="0" indent="0" marL="0" algn="l"><a:buNone /></a:pPr><a:r><a:rPr b="1" /><a:t>[IMPLEMENTED]</a:t></a:r></a:p></a:txBody></a:tc><a:tc><a:txBody><a:bodyPr /><a:lstStyle /><a:p><a:pPr lvl="0" indent="0" marL="0" algn="l"><a:buNone /></a:pPr><a:r><a:rPr /><a:t>C4: a four-action controller, recalibration bounded to </a:t></a:r><a14:m><m:oMath xmlns:m="http://schemas.openxmlformats.org/officeDocument/2006/math"><m:r><m:rPr><m:sty m:val="p" /></m:rPr><m:t>[</m:t></m:r><m:sSub><m:e><m:r><m:t>θ</m:t></m:r></m:e><m:sub><m:r><m:t>0</m:t></m:r></m:sub></m:sSub><m:r><m:rPr><m:sty m:val="p" /></m:rPr><m:t>,</m:t></m:r><m:r><m:t>4</m:t></m:r><m:sSub><m:e><m:r><m:t>θ</m:t></m:r></m:e><m:sub><m:r><m:t>0</m:t></m:r></m:sub></m:sSub><m:r><m:rPr><m:sty m:val="p" /></m:rPr><m:t>]</m:t></m:r></m:oMath></a14:m></a:p></a:txBody></a:tc></a:tr><a:tr h="0"><a:tc><a:txBody><a:bodyPr /><a:lstStyle /><a:p><a:pPr lvl="0" indent="0" marL="0" algn="l"><a:buNone /></a:pPr><a:r><a:rPr b="1" /><a:t>[MEASURED]</a:t></a:r></a:p></a:txBody></a:tc><a:tc><a:txBody><a:bodyPr /><a:lstStyle /><a:p><a:pPr lvl="0" indent="0" marL="0" algn="l"><a:buNone /></a:pPr><a:r><a:rPr /><a:t>C5: identical to fixed on SKAB, so no harm and no benefit</a:t></a:r></a:p></a:txBody></a:tc></a:tr><a:tr h="0"><a:tc><a:txBody><a:bodyPr /><a:lstStyle /><a:p><a:pPr lvl="0" indent="0" marL="0" algn="l"><a:buNone /></a:pPr><a:r><a:rPr b="1" /><a:t>[MEASURED]</a:t></a:r></a:p></a:txBody></a:tc><a:tc><a:txBody><a:bodyPr /><a:lstStyle /><a:p><a:pPr lvl="0" indent="0" marL="0" algn="l"><a:buNone /></a:pPr><a:r><a:rPr /><a:t>C6: under stress it works on a step and fails on a ramp</a:t></a:r></a:p></a:txBody></a:tc></a:tr><a:tr h="0"><a:tc><a:txBody><a:bodyPr /><a:lstStyle /><a:p><a:pPr lvl="0" indent="0" marL="0" algn="l"><a:buNone /></a:pPr><a:r><a:rPr b="1" /><a:t>[PROPOSED]</a:t></a:r></a:p></a:txBody></a:tc><a:tc><a:txBody><a:bodyPr /><a:lstStyle /><a:p><a:pPr lvl="0" indent="0" marL="0" algn="l"><a:buNone /></a:pPr><a:r><a:rPr /><a:t>C7: a benefit on real regime changes, decided by a kill test</a:t></a:r></a:p></a:txBody></a:tc></a:tr></a:tbl></a:graphicData></a:graphic></p:graphicFrame></p:spTree></p:cSld></p:sld>
+<file path=ppt/slides/slide5.xml><?xml version="1.0" encoding="UTF-8"?><p:sld xmlns:a="http://schemas.openxmlformats.org/drawingml/2006/main" xmlns:r="http://schemas.openxmlformats.org/officeDocument/2006/relationships" xmlns:p="http://schemas.openxmlformats.org/presentationml/2006/main"><p:cSld><p:spTree><p:nvGrpSpPr><p:cNvPr id="1" name="" /><p:cNvGrpSpPr /><p:nvPr /></p:nvGrpSpPr><p:grpSpPr><a:xfrm><a:off x="0" y="0" /><a:ext cx="0" cy="0" /><a:chOff x="0" y="0" /><a:chExt cx="0" cy="0" /></a:xfrm></p:grpSpPr><p:sp><p:nvSpPr><p:cNvPr id="2" name="Title 1" /><p:cNvSpPr><a:spLocks noGrp="1" /></p:cNvSpPr><p:nvPr><p:ph type="title" /></p:nvPr></p:nvSpPr><p:spPr><a:xfrm><a:off x="457201" y="204787" /><a:ext cx="3008313" cy="871538" /></a:xfrm></p:spPr><p:txBody><a:bodyPr /><a:lstStyle /><a:p><a:pPr lvl="0" indent="0" marL="0"><a:buNone /></a:pPr><a:r><a:rPr /><a:t>Our direction: recalibration as a guarded, auditable action</a:t></a:r></a:p></p:txBody></p:sp><p:sp><p:nvSpPr><p:cNvPr id="4" name="Text Placeholder 3" /><p:cNvSpPr><a:spLocks noGrp="1" /></p:cNvSpPr><p:nvPr><p:ph idx="2" sz="half" type="body" /></p:nvPr></p:nvSpPr><p:spPr /><p:txBody><a:bodyPr /><a:lstStyle /><a:p><a:pPr lvl="0" indent="0" marL="0"><a:buNone /></a:pPr><a:r><a:rPr /><a:t>Recalibrate only as a deliberate decision, from data chosen </a:t></a:r><a:r><a:rPr b="1" /><a:t>neither by the threshold itself nor unconditionally</a:t></a:r><a:r><a:rPr /><a:t>, and judge every policy on </a:t></a:r><a:r><a:rPr b="1" /><a:t>identical scores</a:t></a:r><a:r><a:rPr /><a:t>. Tags: PROVED = theorem · MEASURED = saved, recomputed result · IMPLEMENTED = tested code · PROPOSED = not yet tested.</a:t></a:r></a:p></p:txBody></p:sp><p:graphicFrame><p:nvGraphicFramePr><p:cNvPr id="6" name="Content Placeholder 5" /><p:cNvGraphicFramePr><a:graphicFrameLocks noGrp="1" /></p:cNvGraphicFramePr><p:nvPr><p:ph idx="1" /></p:nvPr></p:nvGraphicFramePr><p:xfrm><a:off x="3568700" y="203200" /><a:ext cx="5105400" cy="4381500" /></p:xfrm><a:graphic><a:graphicData uri="http://schemas.openxmlformats.org/drawingml/2006/table"><a:tbl><a:tblPr firstRow="1" bandRow="1"><a:tableStyleId>{5C22544A-7EE6-4342-B048-85BDC9FD1C3A}</a:tableStyleId></a:tblPr><a:tblGrid><a:gridCol w="965200" /><a:gridCol w="4140200" /></a:tblGrid><a:tr h="0"><a:tc><a:txBody><a:bodyPr /><a:lstStyle /><a:p><a:pPr lvl="0" indent="0" marL="0" algn="l"><a:buNone /></a:pPr><a:r><a:rPr /><a:t>Evidence</a:t></a:r></a:p></a:txBody><a:tcPr /></a:tc><a:tc><a:txBody><a:bodyPr /><a:lstStyle /><a:p><a:pPr lvl="0" indent="0" marL="0" algn="l"><a:buNone /></a:pPr><a:r><a:rPr /><a:t>What we claim</a:t></a:r></a:p></a:txBody><a:tcPr /></a:tc></a:tr><a:tr h="0"><a:tc><a:txBody><a:bodyPr /><a:lstStyle /><a:p><a:pPr lvl="0" indent="0" marL="0" algn="l"><a:buNone /></a:pPr><a:r><a:rPr b="1" /><a:t>[PROVED]</a:t></a:r></a:p></a:txBody></a:tc><a:tc><a:txBody><a:bodyPr /><a:lstStyle /><a:p><a:pPr lvl="0" indent="0" marL="0" algn="l"><a:buNone /></a:pPr><a:r><a:rPr /><a:t>C1: learning only from “normal” windows means the threshold never rises</a:t></a:r></a:p></a:txBody></a:tc></a:tr><a:tr h="0"><a:tc><a:txBody><a:bodyPr /><a:lstStyle /><a:p><a:pPr lvl="0" indent="0" marL="0" algn="l"><a:buNone /></a:pPr><a:r><a:rPr b="1" /><a:t>[MEASURED]</a:t></a:r></a:p></a:txBody></a:tc><a:tc><a:txBody><a:bodyPr /><a:lstStyle /><a:p><a:pPr lvl="0" indent="0" marL="0" algn="l"><a:buNone /></a:pPr><a:r><a:rPr /><a:t>C2: on SKAB that costs 16.2× and 3.9× the alert windows</a:t></a:r></a:p></a:txBody></a:tc></a:tr><a:tr h="0"><a:tc><a:txBody><a:bodyPr /><a:lstStyle /><a:p><a:pPr lvl="0" indent="0" marL="0" algn="l"><a:buNone /></a:pPr><a:r><a:rPr b="1" /><a:t>[MEASURED]</a:t></a:r></a:p></a:txBody></a:tc><a:tc><a:txBody><a:bodyPr /><a:lstStyle /><a:p><a:pPr lvl="0" indent="0" marL="0" algn="l"><a:buNone /></a:pPr><a:r><a:rPr /><a:t>C3: the scorer, not the policy, limits detection</a:t></a:r></a:p></a:txBody></a:tc></a:tr><a:tr h="0"><a:tc><a:txBody><a:bodyPr /><a:lstStyle /><a:p><a:pPr lvl="0" indent="0" marL="0" algn="l"><a:buNone /></a:pPr><a:r><a:rPr b="1" /><a:t>[IMPLEMENTED]</a:t></a:r></a:p></a:txBody></a:tc><a:tc><a:txBody><a:bodyPr /><a:lstStyle /><a:p><a:pPr lvl="0" indent="0" marL="0" algn="l"><a:buNone /></a:pPr><a:r><a:rPr /><a:t>C4: a four-action controller, recalibration bounded to </a:t></a:r><a14:m><m:oMath xmlns:m="http://schemas.openxmlformats.org/officeDocument/2006/math"><m:r><m:rPr><m:sty m:val="p" /></m:rPr><m:t>[</m:t></m:r><m:sSub><m:e><m:r><m:t>θ</m:t></m:r></m:e><m:sub><m:r><m:t>0</m:t></m:r></m:sub></m:sSub><m:r><m:rPr><m:sty m:val="p" /></m:rPr><m:t>,</m:t></m:r><m:r><m:t>4</m:t></m:r><m:sSub><m:e><m:r><m:t>θ</m:t></m:r></m:e><m:sub><m:r><m:t>0</m:t></m:r></m:sub></m:sSub><m:r><m:rPr><m:sty m:val="p" /></m:rPr><m:t>]</m:t></m:r></m:oMath></a14:m></a:p></a:txBody></a:tc></a:tr><a:tr h="0"><a:tc><a:txBody><a:bodyPr /><a:lstStyle /><a:p><a:pPr lvl="0" indent="0" marL="0" algn="l"><a:buNone /></a:pPr><a:r><a:rPr b="1" /><a:t>[MEASURED]</a:t></a:r></a:p></a:txBody></a:tc><a:tc><a:txBody><a:bodyPr /><a:lstStyle /><a:p><a:pPr lvl="0" indent="0" marL="0" algn="l"><a:buNone /></a:pPr><a:r><a:rPr /><a:t>C5: identical to fixed on SKAB, so no harm and no benefit</a:t></a:r></a:p></a:txBody></a:tc></a:tr><a:tr h="0"><a:tc><a:txBody><a:bodyPr /><a:lstStyle /><a:p><a:pPr lvl="0" indent="0" marL="0" algn="l"><a:buNone /></a:pPr><a:r><a:rPr b="1" /><a:t>[MEASURED]</a:t></a:r></a:p></a:txBody></a:tc><a:tc><a:txBody><a:bodyPr /><a:lstStyle /><a:p><a:pPr lvl="0" indent="0" marL="0" algn="l"><a:buNone /></a:pPr><a:r><a:rPr /><a:t>C6: a synthetic step cuts alerts and later faults remain visible; a ramp remains costly</a:t></a:r></a:p></a:txBody></a:tc></a:tr><a:tr h="0"><a:tc><a:txBody><a:bodyPr /><a:lstStyle /><a:p><a:pPr lvl="0" indent="0" marL="0" algn="l"><a:buNone /></a:pPr><a:r><a:rPr b="1" /><a:t>[PROPOSED]</a:t></a:r></a:p></a:txBody></a:tc><a:tc><a:txBody><a:bodyPr /><a:lstStyle /><a:p><a:pPr lvl="0" indent="0" marL="0" algn="l"><a:buNone /></a:pPr><a:r><a:rPr /><a:t>C7: a benefit on real regime changes, decided by a kill test</a:t></a:r></a:p></a:txBody></a:tc></a:tr></a:tbl></a:graphicData></a:graphic></p:graphicFrame></p:spTree></p:cSld></p:sld>
 </file>
 
 <file path=ppt/slides/slide6.xml><?xml version="1.0" encoding="utf-8"?>

</xml_diff>

<commit_message>
docs(slides): explain all seven synthetic cases in the notes
Give the presenter a compact definition of Y1 through Y7, including the fault after the benign step ends in Y7. Narrow C5 to the observed SKAB result. Rebuild the slide PDF and PowerPoint notes from the source.

Verification: the documented build passed at 15 slides with 14 speaker-note slides, every slide number traced to the report, and the refreshed checksums validated.
</commit_message>
<xml_diff>
--- a/deliverables/Phase-I-Slides.pptx
+++ b/deliverables/Phase-I-Slides.pptx
@@ -712,7 +712,7 @@
             </a:pPr>
             <a:r>
               <a:rPr/>
-              <a:t>These engineered cases show the mechanism and its failures. On a clean benign step it adapts and cuts false-alert time from 597 to 16 while deciding on every window. After adapting it still catches later faults. Y5 is a spiky fault without a preceding step; it tests the cost of deferring at onset. Y6 is a benign step beyond the cap: keeping the cap produces 757 non-event samples, while removing it produces 16, but also lowers Y3 fault visibility from 0.29 to 0.16. On the Y2 ramp it recalibrates once, defers three times, then produces 204 non-event samples over 50 episodes, versus 577 with no deferral. A fault shaped exactly like a benign step is absorbed; we declared that limit in advance, because no label-free rule can tell the two apart.</a:t>
+              <a:t>These seven engineered cases test the mechanism. Y1 is a benign step: non-event duration falls from 597 to 16 at full coverage. Y2 is a benign ramp: one recalibration, three deferrals, then 204 samples over 50 episodes; no deferral gives 577. Y3 adds a spiky fault during Y1’s step. Y4 labels that step itself as a fault, which the controller absorbs as declared. Y5 is a spiky fault alone, testing onset deferral. Y6 is a step beyond the cap: 757 samples with it, 16 without it, while no-cap Y3 fault visibility falls from 0.29 to 0.16. Y7 ends the step before a later spiky fault, testing return to the anchor. These cases do not establish real-world benefit.</a:t>
             </a:r>
           </a:p>
         </p:txBody>
@@ -6472,7 +6472,7 @@
 </p:sld>
 </file>
 
-<file path=ppt/slides/slide5.xml><?xml version="1.0" encoding="UTF-8"?><p:sld xmlns:a="http://schemas.openxmlformats.org/drawingml/2006/main" xmlns:r="http://schemas.openxmlformats.org/officeDocument/2006/relationships" xmlns:p="http://schemas.openxmlformats.org/presentationml/2006/main"><p:cSld><p:spTree><p:nvGrpSpPr><p:cNvPr id="1" name="" /><p:cNvGrpSpPr /><p:nvPr /></p:nvGrpSpPr><p:grpSpPr><a:xfrm><a:off x="0" y="0" /><a:ext cx="0" cy="0" /><a:chOff x="0" y="0" /><a:chExt cx="0" cy="0" /></a:xfrm></p:grpSpPr><p:sp><p:nvSpPr><p:cNvPr id="2" name="Title 1" /><p:cNvSpPr><a:spLocks noGrp="1" /></p:cNvSpPr><p:nvPr><p:ph type="title" /></p:nvPr></p:nvSpPr><p:spPr><a:xfrm><a:off x="457201" y="204787" /><a:ext cx="3008313" cy="871538" /></a:xfrm></p:spPr><p:txBody><a:bodyPr /><a:lstStyle /><a:p><a:pPr lvl="0" indent="0" marL="0"><a:buNone /></a:pPr><a:r><a:rPr /><a:t>Our direction: recalibration as a guarded, auditable action</a:t></a:r></a:p></p:txBody></p:sp><p:sp><p:nvSpPr><p:cNvPr id="4" name="Text Placeholder 3" /><p:cNvSpPr><a:spLocks noGrp="1" /></p:cNvSpPr><p:nvPr><p:ph idx="2" sz="half" type="body" /></p:nvPr></p:nvSpPr><p:spPr /><p:txBody><a:bodyPr /><a:lstStyle /><a:p><a:pPr lvl="0" indent="0" marL="0"><a:buNone /></a:pPr><a:r><a:rPr /><a:t>Recalibrate only as a deliberate decision, from data chosen </a:t></a:r><a:r><a:rPr b="1" /><a:t>neither by the threshold itself nor unconditionally</a:t></a:r><a:r><a:rPr /><a:t>, and judge every policy on </a:t></a:r><a:r><a:rPr b="1" /><a:t>identical scores</a:t></a:r><a:r><a:rPr /><a:t>. Tags: PROVED = theorem · MEASURED = saved, recomputed result · IMPLEMENTED = tested code · PROPOSED = not yet tested.</a:t></a:r></a:p></p:txBody></p:sp><p:graphicFrame><p:nvGraphicFramePr><p:cNvPr id="6" name="Content Placeholder 5" /><p:cNvGraphicFramePr><a:graphicFrameLocks noGrp="1" /></p:cNvGraphicFramePr><p:nvPr><p:ph idx="1" /></p:nvPr></p:nvGraphicFramePr><p:xfrm><a:off x="3568700" y="203200" /><a:ext cx="5105400" cy="4381500" /></p:xfrm><a:graphic><a:graphicData uri="http://schemas.openxmlformats.org/drawingml/2006/table"><a:tbl><a:tblPr firstRow="1" bandRow="1"><a:tableStyleId>{5C22544A-7EE6-4342-B048-85BDC9FD1C3A}</a:tableStyleId></a:tblPr><a:tblGrid><a:gridCol w="965200" /><a:gridCol w="4140200" /></a:tblGrid><a:tr h="0"><a:tc><a:txBody><a:bodyPr /><a:lstStyle /><a:p><a:pPr lvl="0" indent="0" marL="0" algn="l"><a:buNone /></a:pPr><a:r><a:rPr /><a:t>Evidence</a:t></a:r></a:p></a:txBody><a:tcPr /></a:tc><a:tc><a:txBody><a:bodyPr /><a:lstStyle /><a:p><a:pPr lvl="0" indent="0" marL="0" algn="l"><a:buNone /></a:pPr><a:r><a:rPr /><a:t>What we claim</a:t></a:r></a:p></a:txBody><a:tcPr /></a:tc></a:tr><a:tr h="0"><a:tc><a:txBody><a:bodyPr /><a:lstStyle /><a:p><a:pPr lvl="0" indent="0" marL="0" algn="l"><a:buNone /></a:pPr><a:r><a:rPr b="1" /><a:t>[PROVED]</a:t></a:r></a:p></a:txBody></a:tc><a:tc><a:txBody><a:bodyPr /><a:lstStyle /><a:p><a:pPr lvl="0" indent="0" marL="0" algn="l"><a:buNone /></a:pPr><a:r><a:rPr /><a:t>C1: learning only from “normal” windows means the threshold never rises</a:t></a:r></a:p></a:txBody></a:tc></a:tr><a:tr h="0"><a:tc><a:txBody><a:bodyPr /><a:lstStyle /><a:p><a:pPr lvl="0" indent="0" marL="0" algn="l"><a:buNone /></a:pPr><a:r><a:rPr b="1" /><a:t>[MEASURED]</a:t></a:r></a:p></a:txBody></a:tc><a:tc><a:txBody><a:bodyPr /><a:lstStyle /><a:p><a:pPr lvl="0" indent="0" marL="0" algn="l"><a:buNone /></a:pPr><a:r><a:rPr /><a:t>C2: on SKAB that costs 16.2× and 3.9× the alert windows</a:t></a:r></a:p></a:txBody></a:tc></a:tr><a:tr h="0"><a:tc><a:txBody><a:bodyPr /><a:lstStyle /><a:p><a:pPr lvl="0" indent="0" marL="0" algn="l"><a:buNone /></a:pPr><a:r><a:rPr b="1" /><a:t>[MEASURED]</a:t></a:r></a:p></a:txBody></a:tc><a:tc><a:txBody><a:bodyPr /><a:lstStyle /><a:p><a:pPr lvl="0" indent="0" marL="0" algn="l"><a:buNone /></a:pPr><a:r><a:rPr /><a:t>C3: the scorer, not the policy, limits detection</a:t></a:r></a:p></a:txBody></a:tc></a:tr><a:tr h="0"><a:tc><a:txBody><a:bodyPr /><a:lstStyle /><a:p><a:pPr lvl="0" indent="0" marL="0" algn="l"><a:buNone /></a:pPr><a:r><a:rPr b="1" /><a:t>[IMPLEMENTED]</a:t></a:r></a:p></a:txBody></a:tc><a:tc><a:txBody><a:bodyPr /><a:lstStyle /><a:p><a:pPr lvl="0" indent="0" marL="0" algn="l"><a:buNone /></a:pPr><a:r><a:rPr /><a:t>C4: a four-action controller, recalibration bounded to </a:t></a:r><a14:m><m:oMath xmlns:m="http://schemas.openxmlformats.org/officeDocument/2006/math"><m:r><m:rPr><m:sty m:val="p" /></m:rPr><m:t>[</m:t></m:r><m:sSub><m:e><m:r><m:t>θ</m:t></m:r></m:e><m:sub><m:r><m:t>0</m:t></m:r></m:sub></m:sSub><m:r><m:rPr><m:sty m:val="p" /></m:rPr><m:t>,</m:t></m:r><m:r><m:t>4</m:t></m:r><m:sSub><m:e><m:r><m:t>θ</m:t></m:r></m:e><m:sub><m:r><m:t>0</m:t></m:r></m:sub></m:sSub><m:r><m:rPr><m:sty m:val="p" /></m:rPr><m:t>]</m:t></m:r></m:oMath></a14:m></a:p></a:txBody></a:tc></a:tr><a:tr h="0"><a:tc><a:txBody><a:bodyPr /><a:lstStyle /><a:p><a:pPr lvl="0" indent="0" marL="0" algn="l"><a:buNone /></a:pPr><a:r><a:rPr b="1" /><a:t>[MEASURED]</a:t></a:r></a:p></a:txBody></a:tc><a:tc><a:txBody><a:bodyPr /><a:lstStyle /><a:p><a:pPr lvl="0" indent="0" marL="0" algn="l"><a:buNone /></a:pPr><a:r><a:rPr /><a:t>C5: identical to fixed on SKAB, so no harm and no benefit</a:t></a:r></a:p></a:txBody></a:tc></a:tr><a:tr h="0"><a:tc><a:txBody><a:bodyPr /><a:lstStyle /><a:p><a:pPr lvl="0" indent="0" marL="0" algn="l"><a:buNone /></a:pPr><a:r><a:rPr b="1" /><a:t>[MEASURED]</a:t></a:r></a:p></a:txBody></a:tc><a:tc><a:txBody><a:bodyPr /><a:lstStyle /><a:p><a:pPr lvl="0" indent="0" marL="0" algn="l"><a:buNone /></a:pPr><a:r><a:rPr /><a:t>C6: a synthetic step cuts alerts and later faults remain visible; a ramp remains costly</a:t></a:r></a:p></a:txBody></a:tc></a:tr><a:tr h="0"><a:tc><a:txBody><a:bodyPr /><a:lstStyle /><a:p><a:pPr lvl="0" indent="0" marL="0" algn="l"><a:buNone /></a:pPr><a:r><a:rPr b="1" /><a:t>[PROPOSED]</a:t></a:r></a:p></a:txBody></a:tc><a:tc><a:txBody><a:bodyPr /><a:lstStyle /><a:p><a:pPr lvl="0" indent="0" marL="0" algn="l"><a:buNone /></a:pPr><a:r><a:rPr /><a:t>C7: a benefit on real regime changes, decided by a kill test</a:t></a:r></a:p></a:txBody></a:tc></a:tr></a:tbl></a:graphicData></a:graphic></p:graphicFrame></p:spTree></p:cSld></p:sld>
+<file path=ppt/slides/slide5.xml><?xml version="1.0" encoding="UTF-8"?><p:sld xmlns:a="http://schemas.openxmlformats.org/drawingml/2006/main" xmlns:r="http://schemas.openxmlformats.org/officeDocument/2006/relationships" xmlns:p="http://schemas.openxmlformats.org/presentationml/2006/main"><p:cSld><p:spTree><p:nvGrpSpPr><p:cNvPr id="1" name="" /><p:cNvGrpSpPr /><p:nvPr /></p:nvGrpSpPr><p:grpSpPr><a:xfrm><a:off x="0" y="0" /><a:ext cx="0" cy="0" /><a:chOff x="0" y="0" /><a:chExt cx="0" cy="0" /></a:xfrm></p:grpSpPr><p:sp><p:nvSpPr><p:cNvPr id="2" name="Title 1" /><p:cNvSpPr><a:spLocks noGrp="1" /></p:cNvSpPr><p:nvPr><p:ph type="title" /></p:nvPr></p:nvSpPr><p:spPr><a:xfrm><a:off x="457201" y="204787" /><a:ext cx="3008313" cy="871538" /></a:xfrm></p:spPr><p:txBody><a:bodyPr /><a:lstStyle /><a:p><a:pPr lvl="0" indent="0" marL="0"><a:buNone /></a:pPr><a:r><a:rPr /><a:t>Our direction: recalibration as a guarded, auditable action</a:t></a:r></a:p></p:txBody></p:sp><p:sp><p:nvSpPr><p:cNvPr id="4" name="Text Placeholder 3" /><p:cNvSpPr><a:spLocks noGrp="1" /></p:cNvSpPr><p:nvPr><p:ph idx="2" sz="half" type="body" /></p:nvPr></p:nvSpPr><p:spPr /><p:txBody><a:bodyPr /><a:lstStyle /><a:p><a:pPr lvl="0" indent="0" marL="0"><a:buNone /></a:pPr><a:r><a:rPr /><a:t>Recalibrate only as a deliberate decision, from data chosen </a:t></a:r><a:r><a:rPr b="1" /><a:t>neither by the threshold itself nor unconditionally</a:t></a:r><a:r><a:rPr /><a:t>, and judge every policy on </a:t></a:r><a:r><a:rPr b="1" /><a:t>identical scores</a:t></a:r><a:r><a:rPr /><a:t>. Tags: PROVED = theorem · MEASURED = saved, recomputed result · IMPLEMENTED = tested code · PROPOSED = not yet tested.</a:t></a:r></a:p></p:txBody></p:sp><p:graphicFrame><p:nvGraphicFramePr><p:cNvPr id="6" name="Content Placeholder 5" /><p:cNvGraphicFramePr><a:graphicFrameLocks noGrp="1" /></p:cNvGraphicFramePr><p:nvPr><p:ph idx="1" /></p:nvPr></p:nvGraphicFramePr><p:xfrm><a:off x="3568700" y="203200" /><a:ext cx="5105400" cy="4381500" /></p:xfrm><a:graphic><a:graphicData uri="http://schemas.openxmlformats.org/drawingml/2006/table"><a:tbl><a:tblPr firstRow="1" bandRow="1"><a:tableStyleId>{5C22544A-7EE6-4342-B048-85BDC9FD1C3A}</a:tableStyleId></a:tblPr><a:tblGrid><a:gridCol w="965200" /><a:gridCol w="4140200" /></a:tblGrid><a:tr h="0"><a:tc><a:txBody><a:bodyPr /><a:lstStyle /><a:p><a:pPr lvl="0" indent="0" marL="0" algn="l"><a:buNone /></a:pPr><a:r><a:rPr /><a:t>Evidence</a:t></a:r></a:p></a:txBody><a:tcPr /></a:tc><a:tc><a:txBody><a:bodyPr /><a:lstStyle /><a:p><a:pPr lvl="0" indent="0" marL="0" algn="l"><a:buNone /></a:pPr><a:r><a:rPr /><a:t>What we claim</a:t></a:r></a:p></a:txBody><a:tcPr /></a:tc></a:tr><a:tr h="0"><a:tc><a:txBody><a:bodyPr /><a:lstStyle /><a:p><a:pPr lvl="0" indent="0" marL="0" algn="l"><a:buNone /></a:pPr><a:r><a:rPr b="1" /><a:t>[PROVED]</a:t></a:r></a:p></a:txBody></a:tc><a:tc><a:txBody><a:bodyPr /><a:lstStyle /><a:p><a:pPr lvl="0" indent="0" marL="0" algn="l"><a:buNone /></a:pPr><a:r><a:rPr /><a:t>C1: learning only from “normal” windows means the threshold never rises</a:t></a:r></a:p></a:txBody></a:tc></a:tr><a:tr h="0"><a:tc><a:txBody><a:bodyPr /><a:lstStyle /><a:p><a:pPr lvl="0" indent="0" marL="0" algn="l"><a:buNone /></a:pPr><a:r><a:rPr b="1" /><a:t>[MEASURED]</a:t></a:r></a:p></a:txBody></a:tc><a:tc><a:txBody><a:bodyPr /><a:lstStyle /><a:p><a:pPr lvl="0" indent="0" marL="0" algn="l"><a:buNone /></a:pPr><a:r><a:rPr /><a:t>C2: on SKAB that costs 16.2× and 3.9× the alert windows</a:t></a:r></a:p></a:txBody></a:tc></a:tr><a:tr h="0"><a:tc><a:txBody><a:bodyPr /><a:lstStyle /><a:p><a:pPr lvl="0" indent="0" marL="0" algn="l"><a:buNone /></a:pPr><a:r><a:rPr b="1" /><a:t>[MEASURED]</a:t></a:r></a:p></a:txBody></a:tc><a:tc><a:txBody><a:bodyPr /><a:lstStyle /><a:p><a:pPr lvl="0" indent="0" marL="0" algn="l"><a:buNone /></a:pPr><a:r><a:rPr /><a:t>C3: the scorer, not the policy, limits detection</a:t></a:r></a:p></a:txBody></a:tc></a:tr><a:tr h="0"><a:tc><a:txBody><a:bodyPr /><a:lstStyle /><a:p><a:pPr lvl="0" indent="0" marL="0" algn="l"><a:buNone /></a:pPr><a:r><a:rPr b="1" /><a:t>[IMPLEMENTED]</a:t></a:r></a:p></a:txBody></a:tc><a:tc><a:txBody><a:bodyPr /><a:lstStyle /><a:p><a:pPr lvl="0" indent="0" marL="0" algn="l"><a:buNone /></a:pPr><a:r><a:rPr /><a:t>C4: a four-action controller, recalibration bounded to </a:t></a:r><a14:m><m:oMath xmlns:m="http://schemas.openxmlformats.org/officeDocument/2006/math"><m:r><m:rPr><m:sty m:val="p" /></m:rPr><m:t>[</m:t></m:r><m:sSub><m:e><m:r><m:t>θ</m:t></m:r></m:e><m:sub><m:r><m:t>0</m:t></m:r></m:sub></m:sSub><m:r><m:rPr><m:sty m:val="p" /></m:rPr><m:t>,</m:t></m:r><m:r><m:t>4</m:t></m:r><m:sSub><m:e><m:r><m:t>θ</m:t></m:r></m:e><m:sub><m:r><m:t>0</m:t></m:r></m:sub></m:sSub><m:r><m:rPr><m:sty m:val="p" /></m:rPr><m:t>]</m:t></m:r></m:oMath></a14:m></a:p></a:txBody></a:tc></a:tr><a:tr h="0"><a:tc><a:txBody><a:bodyPr /><a:lstStyle /><a:p><a:pPr lvl="0" indent="0" marL="0" algn="l"><a:buNone /></a:pPr><a:r><a:rPr b="1" /><a:t>[MEASURED]</a:t></a:r></a:p></a:txBody></a:tc><a:tc><a:txBody><a:bodyPr /><a:lstStyle /><a:p><a:pPr lvl="0" indent="0" marL="0" algn="l"><a:buNone /></a:pPr><a:r><a:rPr /><a:t>C5: identical to fixed on SKAB; no benefit observed</a:t></a:r></a:p></a:txBody></a:tc></a:tr><a:tr h="0"><a:tc><a:txBody><a:bodyPr /><a:lstStyle /><a:p><a:pPr lvl="0" indent="0" marL="0" algn="l"><a:buNone /></a:pPr><a:r><a:rPr b="1" /><a:t>[MEASURED]</a:t></a:r></a:p></a:txBody></a:tc><a:tc><a:txBody><a:bodyPr /><a:lstStyle /><a:p><a:pPr lvl="0" indent="0" marL="0" algn="l"><a:buNone /></a:pPr><a:r><a:rPr /><a:t>C6: a synthetic step cuts alerts and later faults remain visible; a ramp remains costly</a:t></a:r></a:p></a:txBody></a:tc></a:tr><a:tr h="0"><a:tc><a:txBody><a:bodyPr /><a:lstStyle /><a:p><a:pPr lvl="0" indent="0" marL="0" algn="l"><a:buNone /></a:pPr><a:r><a:rPr b="1" /><a:t>[PROPOSED]</a:t></a:r></a:p></a:txBody></a:tc><a:tc><a:txBody><a:bodyPr /><a:lstStyle /><a:p><a:pPr lvl="0" indent="0" marL="0" algn="l"><a:buNone /></a:pPr><a:r><a:rPr /><a:t>C7: a benefit on real regime changes, decided by a kill test</a:t></a:r></a:p></a:txBody></a:tc></a:tr></a:tbl></a:graphicData></a:graphic></p:graphicFrame></p:spTree></p:cSld></p:sld>
 </file>
 
 <file path=ppt/slides/slide6.xml><?xml version="1.0" encoding="utf-8"?>

</xml_diff>

<commit_message>
fix(report): restore colored figures and NSUT logo
Use the Overleaf colors for the report pipeline and the two plotted figures, then regenerate the report and slide deliverables from the saved results. Include the NSUT mark on the report cover and both slide title formats through the documented build.

The report and decks pass the documented page, slide, numeric, notes, and layout checks. The saved plot data and the other generated figures are unchanged.
</commit_message>
<xml_diff>
--- a/deliverables/Phase-I-Slides.pptx
+++ b/deliverables/Phase-I-Slides.pptx
@@ -4598,7 +4598,7 @@
 </file>
 
 <file path=ppt/slides/slide1.xml><?xml version="1.0" encoding="utf-8"?>
-<p:sld xmlns:a="http://schemas.openxmlformats.org/drawingml/2006/main" xmlns:r="http://schemas.openxmlformats.org/officeDocument/2006/relationships" xmlns:p="http://schemas.openxmlformats.org/presentationml/2006/main">
+<p:sld xmlns:a="http://schemas.openxmlformats.org/drawingml/2006/main" xmlns:p="http://schemas.openxmlformats.org/presentationml/2006/main" xmlns:r="http://schemas.openxmlformats.org/officeDocument/2006/relationships">
   <p:cSld>
     <p:spTree>
       <p:nvGrpSpPr>
@@ -4705,6 +4705,30 @@
           </a:p>
         </p:txBody>
       </p:sp>
+      <p:pic>
+        <p:nvPicPr>
+          <p:cNvPr id="5" name="NSUT logo"/>
+          <p:cNvPicPr>
+            <a:picLocks noChangeAspect="1"/>
+          </p:cNvPicPr>
+          <p:nvPr/>
+        </p:nvPicPr>
+        <p:blipFill>
+          <a:blip r:embed="rId2"/>
+          <a:stretch>
+            <a:fillRect/>
+          </a:stretch>
+        </p:blipFill>
+        <p:spPr>
+          <a:xfrm>
+            <a:off x="4252000" y="320000"/>
+            <a:ext cx="640000" cy="640000"/>
+          </a:xfrm>
+          <a:prstGeom prst="rect">
+            <a:avLst/>
+          </a:prstGeom>
+        </p:spPr>
+      </p:pic>
     </p:spTree>
   </p:cSld>
 </p:sld>

</xml_diff>